<commit_message>
Add Toolkit local tracing demo
Co-authored-by: Copilot App <223556219+Copilot@users.noreply.github.com>
</commit_message>
<xml_diff>
--- a/decks/day5/module-2-foundry-toolkit-vscode.pptx
+++ b/decks/day5/module-2-foundry-toolkit-vscode.pptx
@@ -6,10 +6,11 @@
   </p:sldMasterIdLst>
   <p:sldIdLst>
     <p:sldId id="256" r:id="rId2"/>
+    <p:sldId id="258" r:id="rId4"/>
     <p:sldId id="257" r:id="rId3"/>
-    <p:sldId id="258" r:id="rId4"/>
     <p:sldId id="259" r:id="rId5"/>
     <p:sldId id="260" r:id="rId6"/>
+    <p:sldId id="262" r:id="rId13"/>
     <p:sldId id="261" r:id="rId7"/>
   </p:sldIdLst>
   <p:notesMasterIdLst>
@@ -507,8 +508,9 @@
           <a:p>
             <a:r>
               <a:rPr lang="en-US" dirty="0"/>
-              <a:t>• Allow 1 minute. Position Toolkit as a VS Code development extension that brings local and Foundry resources into one workspace. The goal is surface selection, not a feature tour or deployment exercise. Continue with the presenter-prepared reference workflow; no attendee project, agent, or prior lab output is required.
-• GROUNDING SOURCE: https://learn.microsoft.com/azure/foundry/how-to/develop/get-started-projects-visual-studio-code</a:t>
+              <a:t>• Allow 1 minute. Position Toolkit as the current VS Code extension for discovering, building, testing, deploying, evaluating, and monitoring AI apps and agents across local and cloud resources. It supports Foundry, external-provider, and local models. Foundry Toolkit is the current name for AI Toolkit and includes capabilities previously provided by the separate Foundry extension. The presenter environment requires the .NET Runtime; validate Foundry Local prerequisites only if showing a local model, which this module does not require. The goal is surface selection, not a feature tour or deployment exercise. Continue with the presenter-prepared reference workflow; no attendee project, agent, or prior lab output is required.
+• GROUNDING SOURCE: https://learn.microsoft.com/azure/foundry/how-to/develop/get-started-projects-visual-studio-code
+• GROUNDING SOURCE: https://code.visualstudio.com/docs/intelligentapps/overview</a:t>
             </a:r>
             <a:endParaRPr lang="en-US" dirty="0"/>
           </a:p>
@@ -622,7 +624,7 @@
           <a:p>
             <a:fld id="{F7021451-1387-4CA6-816F-3879F97B5CBC}" type="slidenum">
               <a:rPr lang="en-US"/>
-              <a:t>2</a:t>
+              <a:t>3</a:t>
             </a:fld>
             <a:endParaRPr lang="en-US"/>
           </a:p>
@@ -687,10 +689,9 @@
           <a:p>
             <a:r>
               <a:rPr lang="en-US" dirty="0"/>
-              <a:t>• Allow 2 minutes. A model performs inference. An agent adds reusable instructions and tools around a model. A conversation persists history across turns. The storage badge describes where a prompt configuration is kept, not where inference runs. Model Playground is for model interactions; agent investigation must also account for instructions, tools, conversations, and runtime activity.
-• GROUNDING SOURCE: https://learn.microsoft.com/azure/foundry/agents/concepts/runtime-components
-• GROUNDING SOURCE: https://learn.microsoft.com/azure/foundry/how-to/develop/get-started-projects-visual-studio-code
-• GROUNDING SOURCE: https://learn.microsoft.com/azure/foundry/how-to/develop/create-prompt-agent-visual-studio-code</a:t>
+              <a:t>• Allow 2 minutes. Foundry Toolkit separates resources that you have from actions that you can take. My Resources groups Local Resources, Your Foundry Project, and Connected Resources. Developer Tools groups work into Discover, Build, and Monitor. Help and Feedback links to documentation, release information, issue reporting, and the community. Exact entries can change as the extension evolves, so use the installed Toolkit view as the authoritative inventory.
+• GROUNDING SOURCE: https://learn.microsoft.com/en-us/azure/foundry/how-to/develop/get-started-projects-visual-studio-code#how-the-toolkit-workspace-is-organized
+• GROUNDING SOURCE: https://code.visualstudio.com/docs/intelligentapps/overview#_explore-foundry-toolkit</a:t>
             </a:r>
             <a:endParaRPr lang="en-US" dirty="0"/>
           </a:p>
@@ -713,7 +714,7 @@
           <a:p>
             <a:fld id="{F7021451-1387-4CA6-816F-3879F97B5CBC}" type="slidenum">
               <a:rPr lang="en-US"/>
-              <a:t>3</a:t>
+              <a:t>2</a:t>
             </a:fld>
             <a:endParaRPr lang="en-US"/>
           </a:p>
@@ -778,7 +779,7 @@
           <a:p>
             <a:r>
               <a:rPr lang="en-US" dirty="0"/>
-              <a:t>• Allow 2 minutes. Read the columns as capability boundaries, not a maturity ranking. A Local badge can sit beside a cloud model. Local prompts have their own local-tool, structured-output, and dataset-evaluation paths. A saved Foundry agent creates immutable versions and enables version-linked conversations, tracing, generated client code, and service evaluation paths. Unsaved edits are drafts; save before relying on version evidence, and verify which version generated evaluation code actually targets.
+              <a:t>• Allow 2 minutes. Read the columns as capability boundaries, not a maturity ranking. A locally stored prompt can still use a cloud model, so storage location does not identify where inference runs. Local prompts have their own local-tool, structured-output, and dataset-evaluation paths. A saved Foundry agent creates immutable versions and enables version-linked conversations, tracing, generated client code, and service evaluation paths. Unsaved edits are drafts; save before relying on version evidence, and verify which version generated evaluation code actually targets.
 • GROUNDING SOURCE: https://learn.microsoft.com/azure/foundry/how-to/develop/create-prompt-agent-visual-studio-code
 • GROUNDING SOURCE: https://learn.microsoft.com/azure/foundry/agents/concepts/development-lifecycle</a:t>
             </a:r>
@@ -871,7 +872,8 @@
               <a:t>• Allow 6 minutes. Agent Inspector is a preview, browser-based view of a presenter-prepared local HTTP/SSE agent. Show streaming response and tool activity, and show workflow visualization only if the rehearsed language and installed Toolkit version support it. The localhost target is not a deployed endpoint, and opening Inspector does not automatically export the cloud trace seen in Module 1.
 • GROUNDING SOURCE: https://learn.microsoft.com/azure/foundry/agents/how-to/agent-inspector
 • GROUNDING SOURCE: https://learn.microsoft.com/azure/foundry/agents/how-to/vs-code-agents-workflow-pro-code
-• GROUNDING SOURCE: https://learn.microsoft.com/azure/foundry/how-to/develop/get-started-projects-visual-studio-code</a:t>
+• GROUNDING SOURCE: https://learn.microsoft.com/azure/foundry/how-to/develop/get-started-projects-visual-studio-code
+• GROUNDING SOURCE: https://code.visualstudio.com/docs/intelligentapps/overview</a:t>
             </a:r>
             <a:endParaRPr lang="en-US" dirty="0"/>
           </a:p>
@@ -959,11 +961,12 @@
           <a:p>
             <a:r>
               <a:rPr lang="en-US" dirty="0"/>
-              <a:t>• Allow 2 minutes. Run the checkpoint: point to a Local badge beside an existing cloud model and ask whether data necessarily stays on the laptop and whether its evaluation view matches a saved Foundry agent. Both answers are no; inspect the model endpoint and configuration type. Exact Toolkit features vary by installed version, so use the extension view as the inventory and do not promise unsupported workflow visualization.
+              <a:t>• Allow 2 minutes. Run the checkpoint: point to a locally stored prompt configured with an existing cloud model and ask whether its storage location proves that data and inference remain on the laptop or that its evaluation view matches a saved Foundry agent. Both answers are no; inspect the model endpoint and configuration type. Exact Toolkit features vary by installed version, so use the extension view as the inventory and do not promise unsupported workflow visualization.
 • GROUNDING SOURCE: https://learn.microsoft.com/azure/foundry/how-to/develop/get-started-projects-visual-studio-code
 • GROUNDING SOURCE: https://learn.microsoft.com/azure/foundry/agents/how-to/agent-inspector
 • GROUNDING SOURCE: https://learn.microsoft.com/azure/foundry/how-to/develop/create-prompt-agent-visual-studio-code
-• GROUNDING SOURCE: https://learn.microsoft.com/azure/foundry/how-to/develop/use-microsoft-foundry-skill</a:t>
+• GROUNDING SOURCE: https://learn.microsoft.com/azure/foundry/how-to/develop/use-microsoft-foundry-skill
+• GROUNDING SOURCE: https://code.visualstudio.com/docs/intelligentapps/overview</a:t>
             </a:r>
             <a:endParaRPr lang="en-US" dirty="0"/>
           </a:p>
@@ -986,7 +989,7 @@
           <a:p>
             <a:fld id="{F7021451-1387-4CA6-816F-3879F97B5CBC}" type="slidenum">
               <a:rPr lang="en-US"/>
-              <a:t>6</a:t>
+              <a:t>7</a:t>
             </a:fld>
             <a:endParaRPr lang="en-US"/>
           </a:p>
@@ -996,6 +999,96 @@
     <p:extLst>
       <p:ext uri="{BB962C8B-B14F-4D97-AF65-F5344CB8AC3E}">
         <p14:creationId xmlns:p14="http://schemas.microsoft.com/office/powerpoint/2010/main" val="1024086991"/>
+      </p:ext>
+    </p:extLst>
+  </p:cSld>
+  <p:clrMapOvr>
+    <a:masterClrMapping/>
+  </p:clrMapOvr>
+</p:notes>
+</file>
+
+<file path=ppt/notesSlides/notesSlide7.xml><?xml version="1.0" encoding="utf-8"?>
+<p:notes xmlns:a="http://schemas.openxmlformats.org/drawingml/2006/main" xmlns:r="http://schemas.openxmlformats.org/officeDocument/2006/relationships" xmlns:p="http://schemas.openxmlformats.org/presentationml/2006/main">
+  <p:cSld>
+    <p:spTree>
+      <p:nvGrpSpPr>
+        <p:cNvPr id="1" name=""/>
+        <p:cNvGrpSpPr/>
+        <p:nvPr/>
+      </p:nvGrpSpPr>
+      <p:grpSpPr>
+        <a:xfrm>
+          <a:off x="0" y="0"/>
+          <a:ext cx="0" cy="0"/>
+          <a:chOff x="0" y="0"/>
+          <a:chExt cx="0" cy="0"/>
+        </a:xfrm>
+      </p:grpSpPr>
+      <p:sp>
+        <p:nvSpPr>
+          <p:cNvPr id="2" name="Slide Image Placeholder 1"/>
+          <p:cNvSpPr>
+            <a:spLocks noGrp="1" noRot="1" noChangeAspect="1"/>
+          </p:cNvSpPr>
+          <p:nvPr>
+            <p:ph type="sldImg"/>
+          </p:nvPr>
+        </p:nvSpPr>
+        <p:spPr/>
+      </p:sp>
+      <p:sp>
+        <p:nvSpPr>
+          <p:cNvPr id="3" name="Notes Placeholder 2"/>
+          <p:cNvSpPr>
+            <a:spLocks noGrp="1"/>
+          </p:cNvSpPr>
+          <p:nvPr>
+            <p:ph type="body" idx="1"/>
+          </p:nvPr>
+        </p:nvSpPr>
+        <p:spPr/>
+        <p:txBody>
+          <a:bodyPr/>
+          <a:lstStyle/>
+          <a:p>
+            <a:r>
+              <a:rPr lang="en-US" dirty="0"/>
+              <a:t>• Allow 6 minutes. Open Developer Tools &gt; Monitor &gt; Tracing and start the Toolkit's local OTLP collector before running the prepared Agent Framework WeatherAgent sample. The sample exports to the collector on localhost:4317; refresh the trace list and inspect the Weather Agent Chat trace, automatic agent/model/tool spans, durations, status, and metadata. Content capture is enabled only for the synthetic weather prompts used in this controlled demonstration. Local trace storage is separate from Application Insights, and the configured Foundry model still performs inference remotely. Stop the collector and remove the local demo traces during cleanup.
+• GROUNDING SOURCE: https://code.visualstudio.com/docs/intelligentapps/tracing
+• GROUNDING SOURCE: https://learn.microsoft.com/agent-framework/agents/observability</a:t>
+            </a:r>
+            <a:endParaRPr lang="en-US" dirty="0"/>
+          </a:p>
+        </p:txBody>
+      </p:sp>
+      <p:sp>
+        <p:nvSpPr>
+          <p:cNvPr id="4" name="Slide Number Placeholder 3"/>
+          <p:cNvSpPr>
+            <a:spLocks noGrp="1"/>
+          </p:cNvSpPr>
+          <p:nvPr>
+            <p:ph type="sldNum" sz="quarter" idx="10"/>
+          </p:nvPr>
+        </p:nvSpPr>
+        <p:spPr/>
+        <p:txBody>
+          <a:bodyPr/>
+          <a:lstStyle/>
+          <a:p>
+            <a:fld id="{A7E74D49-939B-4D12-99A8-33893F7A11E2}" type="slidenum">
+              <a:rPr lang="en-US"/>
+              <a:t>6</a:t>
+            </a:fld>
+            <a:endParaRPr lang="en-US"/>
+          </a:p>
+        </p:txBody>
+      </p:sp>
+    </p:spTree>
+    <p:extLst>
+      <p:ext uri="{BB962C8B-B14F-4D97-AF65-F5344CB8AC3E}">
+        <p14:creationId xmlns:p14="http://schemas.microsoft.com/office/powerpoint/2010/main" val="1267992548"/>
       </p:ext>
     </p:extLst>
   </p:cSld>
@@ -1712,7 +1805,7 @@
                 <a:ea typeface="Aptos" pitchFamily="34" charset="-122"/>
                 <a:cs typeface="Aptos" pitchFamily="34" charset="-120"/>
               </a:rPr>
-              <a:t>Use the right surface for one development question — and know what that surface does not prove.</a:t>
+              <a:t>Discover, build, inspect, evaluate, deploy, and monitor in one workspace — then verify the target.</a:t>
             </a:r>
             <a:endParaRPr lang="en-US" sz="1700" dirty="0"/>
           </a:p>
@@ -1831,7 +1924,7 @@
                 <a:ea typeface="Aptos" pitchFamily="34" charset="-122"/>
                 <a:cs typeface="Aptos" pitchFamily="34" charset="-120"/>
               </a:rPr>
-              <a:t>REFERENCE  learn.microsoft.com/azure/foundry/how-to/develop/get-started-projects-visual-studio-code</a:t>
+              <a:t>REFERENCE  learn.microsoft.com/azure/foundry/how-to/develop/get-started-projects-visual-studio-code  ·  +1 more in notes</a:t>
             </a:r>
             <a:endParaRPr lang="en-US" sz="940" dirty="0"/>
           </a:p>
@@ -1866,1004 +1959,6 @@
 </file>
 
 <file path=ppt/slides/slide2.xml><?xml version="1.0" encoding="utf-8"?>
-<p:sld xmlns:a="http://schemas.openxmlformats.org/drawingml/2006/main" xmlns:r="http://schemas.openxmlformats.org/officeDocument/2006/relationships" xmlns:p="http://schemas.openxmlformats.org/presentationml/2006/main">
-  <p:cSld name="Slide 2">
-    <p:bg>
-      <p:bgPr>
-        <a:solidFill>
-          <a:srgbClr val="FCF8FF"/>
-        </a:solidFill>
-      </p:bgPr>
-    </p:bg>
-    <p:spTree>
-      <p:nvGrpSpPr>
-        <p:cNvPr id="1" name=""/>
-        <p:cNvGrpSpPr/>
-        <p:nvPr/>
-      </p:nvGrpSpPr>
-      <p:grpSpPr>
-        <a:xfrm>
-          <a:off x="0" y="0"/>
-          <a:ext cx="0" cy="0"/>
-          <a:chOff x="0" y="0"/>
-          <a:chExt cx="0" cy="0"/>
-        </a:xfrm>
-      </p:grpSpPr>
-      <p:sp>
-        <p:nvSpPr>
-          <p:cNvPr id="2" name="Shape 0"/>
-          <p:cNvSpPr/>
-          <p:nvPr/>
-        </p:nvSpPr>
-        <p:spPr>
-          <a:xfrm>
-            <a:off x="621792" y="438912"/>
-            <a:ext cx="2176272" cy="310896"/>
-          </a:xfrm>
-          <a:prstGeom prst="roundRect">
-            <a:avLst>
-              <a:gd name="adj" fmla="val 23529"/>
-            </a:avLst>
-          </a:prstGeom>
-          <a:solidFill>
-            <a:srgbClr val="28143F"/>
-          </a:solidFill>
-          <a:ln/>
-        </p:spPr>
-      </p:sp>
-      <p:sp>
-        <p:nvSpPr>
-          <p:cNvPr id="3" name="Text 1"/>
-          <p:cNvSpPr/>
-          <p:nvPr/>
-        </p:nvSpPr>
-        <p:spPr>
-          <a:xfrm>
-            <a:off x="768096" y="530352"/>
-            <a:ext cx="1874520" cy="109728"/>
-          </a:xfrm>
-          <a:prstGeom prst="rect">
-            <a:avLst/>
-          </a:prstGeom>
-          <a:noFill/>
-          <a:ln/>
-        </p:spPr>
-        <p:txBody>
-          <a:bodyPr wrap="square" lIns="0" tIns="0" rIns="0" bIns="0" rtlCol="0" anchor="ctr">
-            <a:normAutofit/>
-          </a:bodyPr>
-          <a:lstStyle/>
-          <a:p>
-            <a:pPr indent="0" marL="0">
-              <a:buNone/>
-            </a:pPr>
-            <a:r>
-              <a:rPr lang="en-US" sz="820" b="1" spc="120" kern="0" dirty="0">
-                <a:solidFill>
-                  <a:srgbClr val="FFFFFF"/>
-                </a:solidFill>
-                <a:latin typeface="Aptos" pitchFamily="34" charset="0"/>
-                <a:ea typeface="Aptos" pitchFamily="34" charset="-122"/>
-                <a:cs typeface="Aptos" pitchFamily="34" charset="-120"/>
-              </a:rPr>
-              <a:t>DAY 5  /  MODULE 2  /  DEVELOPER SURFACES</a:t>
-            </a:r>
-            <a:endParaRPr lang="en-US" sz="820" dirty="0"/>
-          </a:p>
-        </p:txBody>
-      </p:sp>
-      <p:sp>
-        <p:nvSpPr>
-          <p:cNvPr id="4" name="Text 2"/>
-          <p:cNvSpPr/>
-          <p:nvPr/>
-        </p:nvSpPr>
-        <p:spPr>
-          <a:xfrm>
-            <a:off x="640080" y="841248"/>
-            <a:ext cx="10012680" cy="475488"/>
-          </a:xfrm>
-          <a:prstGeom prst="rect">
-            <a:avLst/>
-          </a:prstGeom>
-          <a:noFill/>
-          <a:ln/>
-        </p:spPr>
-        <p:txBody>
-          <a:bodyPr wrap="square" lIns="0" tIns="0" rIns="0" bIns="0" rtlCol="0" anchor="ctr">
-            <a:normAutofit/>
-          </a:bodyPr>
-          <a:lstStyle/>
-          <a:p>
-            <a:pPr indent="0" marL="0">
-              <a:buNone/>
-            </a:pPr>
-            <a:r>
-              <a:rPr lang="en-US" sz="3100" b="1" dirty="0">
-                <a:solidFill>
-                  <a:srgbClr val="28143F"/>
-                </a:solidFill>
-                <a:latin typeface="Aptos Display" pitchFamily="34" charset="0"/>
-                <a:ea typeface="Aptos Display" pitchFamily="34" charset="-122"/>
-                <a:cs typeface="Aptos Display" pitchFamily="34" charset="-120"/>
-              </a:rPr>
-              <a:t>Toolkit, Toolbox, and coding skills</a:t>
-            </a:r>
-            <a:endParaRPr lang="en-US" sz="3100" dirty="0"/>
-          </a:p>
-        </p:txBody>
-      </p:sp>
-      <p:sp>
-        <p:nvSpPr>
-          <p:cNvPr id="5" name="Shape 3"/>
-          <p:cNvSpPr/>
-          <p:nvPr/>
-        </p:nvSpPr>
-        <p:spPr>
-          <a:xfrm>
-            <a:off x="10804550" y="436717"/>
-            <a:ext cx="592531" cy="500360"/>
-          </a:xfrm>
-          <a:prstGeom prst="roundRect">
-            <a:avLst>
-              <a:gd name="adj" fmla="val 14620"/>
-            </a:avLst>
-          </a:prstGeom>
-          <a:solidFill>
-            <a:srgbClr val="FFFFFF"/>
-          </a:solidFill>
-          <a:ln w="10160">
-            <a:solidFill>
-              <a:srgbClr val="28143F"/>
-            </a:solidFill>
-            <a:prstDash val="solid"/>
-          </a:ln>
-        </p:spPr>
-      </p:sp>
-      <p:sp>
-        <p:nvSpPr>
-          <p:cNvPr id="6" name="Shape 4"/>
-          <p:cNvSpPr/>
-          <p:nvPr/>
-        </p:nvSpPr>
-        <p:spPr>
-          <a:xfrm>
-            <a:off x="10804550" y="436717"/>
-            <a:ext cx="592531" cy="105339"/>
-          </a:xfrm>
-          <a:prstGeom prst="rect">
-            <a:avLst/>
-          </a:prstGeom>
-          <a:solidFill>
-            <a:srgbClr val="B88AF7"/>
-          </a:solidFill>
-          <a:ln/>
-        </p:spPr>
-      </p:sp>
-      <p:sp>
-        <p:nvSpPr>
-          <p:cNvPr id="7" name="Shape 5"/>
-          <p:cNvSpPr/>
-          <p:nvPr/>
-        </p:nvSpPr>
-        <p:spPr>
-          <a:xfrm>
-            <a:off x="10903306" y="640812"/>
-            <a:ext cx="316017" cy="0"/>
-          </a:xfrm>
-          <a:prstGeom prst="line">
-            <a:avLst/>
-          </a:prstGeom>
-          <a:noFill/>
-          <a:ln w="25400">
-            <a:solidFill>
-              <a:srgbClr val="28143F"/>
-            </a:solidFill>
-            <a:prstDash val="solid"/>
-          </a:ln>
-        </p:spPr>
-      </p:sp>
-      <p:sp>
-        <p:nvSpPr>
-          <p:cNvPr id="8" name="Shape 6"/>
-          <p:cNvSpPr/>
-          <p:nvPr/>
-        </p:nvSpPr>
-        <p:spPr>
-          <a:xfrm>
-            <a:off x="10969142" y="746150"/>
-            <a:ext cx="296266" cy="0"/>
-          </a:xfrm>
-          <a:prstGeom prst="line">
-            <a:avLst/>
-          </a:prstGeom>
-          <a:noFill/>
-          <a:ln w="25400">
-            <a:solidFill>
-              <a:srgbClr val="B88AF7"/>
-            </a:solidFill>
-            <a:prstDash val="solid"/>
-          </a:ln>
-        </p:spPr>
-      </p:sp>
-      <p:sp>
-        <p:nvSpPr>
-          <p:cNvPr id="9" name="Shape 7"/>
-          <p:cNvSpPr/>
-          <p:nvPr/>
-        </p:nvSpPr>
-        <p:spPr>
-          <a:xfrm>
-            <a:off x="10890138" y="844906"/>
-            <a:ext cx="204094" cy="0"/>
-          </a:xfrm>
-          <a:prstGeom prst="line">
-            <a:avLst/>
-          </a:prstGeom>
-          <a:noFill/>
-          <a:ln w="25400">
-            <a:solidFill>
-              <a:srgbClr val="28143F"/>
-            </a:solidFill>
-            <a:prstDash val="solid"/>
-          </a:ln>
-        </p:spPr>
-      </p:sp>
-      <p:sp>
-        <p:nvSpPr>
-          <p:cNvPr id="10" name="Shape 8"/>
-          <p:cNvSpPr/>
-          <p:nvPr/>
-        </p:nvSpPr>
-        <p:spPr>
-          <a:xfrm>
-            <a:off x="11612880" y="457200"/>
-            <a:ext cx="329184" cy="329184"/>
-          </a:xfrm>
-          <a:prstGeom prst="ellipse">
-            <a:avLst/>
-          </a:prstGeom>
-          <a:solidFill>
-            <a:srgbClr val="B88AF7"/>
-          </a:solidFill>
-          <a:ln/>
-        </p:spPr>
-      </p:sp>
-      <p:sp>
-        <p:nvSpPr>
-          <p:cNvPr id="11" name="Text 9"/>
-          <p:cNvSpPr/>
-          <p:nvPr/>
-        </p:nvSpPr>
-        <p:spPr>
-          <a:xfrm>
-            <a:off x="11612880" y="553212"/>
-            <a:ext cx="329184" cy="100584"/>
-          </a:xfrm>
-          <a:prstGeom prst="rect">
-            <a:avLst/>
-          </a:prstGeom>
-          <a:noFill/>
-          <a:ln/>
-        </p:spPr>
-        <p:txBody>
-          <a:bodyPr wrap="square" lIns="0" tIns="0" rIns="0" bIns="0" rtlCol="0" anchor="ctr"/>
-          <a:lstStyle/>
-          <a:p>
-            <a:pPr algn="ctr" indent="0" marL="0">
-              <a:buNone/>
-            </a:pPr>
-            <a:r>
-              <a:rPr lang="en-US" sz="850" b="1" dirty="0">
-                <a:solidFill>
-                  <a:srgbClr val="28143F"/>
-                </a:solidFill>
-                <a:latin typeface="Aptos" pitchFamily="34" charset="0"/>
-                <a:ea typeface="Aptos" pitchFamily="34" charset="-122"/>
-                <a:cs typeface="Aptos" pitchFamily="34" charset="-120"/>
-              </a:rPr>
-              <a:t>02</a:t>
-            </a:r>
-            <a:endParaRPr lang="en-US" sz="850" dirty="0"/>
-          </a:p>
-        </p:txBody>
-      </p:sp>
-      <p:sp>
-        <p:nvSpPr>
-          <p:cNvPr id="12" name="Shape 10"/>
-          <p:cNvSpPr/>
-          <p:nvPr/>
-        </p:nvSpPr>
-        <p:spPr>
-          <a:xfrm>
-            <a:off x="9829800" y="1005840"/>
-            <a:ext cx="2148840" cy="2148840"/>
-          </a:xfrm>
-          <a:prstGeom prst="ellipse">
-            <a:avLst/>
-          </a:prstGeom>
-          <a:solidFill>
-            <a:srgbClr val="F1E8FD"/>
-          </a:solidFill>
-          <a:ln/>
-        </p:spPr>
-      </p:sp>
-      <p:sp>
-        <p:nvSpPr>
-          <p:cNvPr id="13" name="Shape 11"/>
-          <p:cNvSpPr/>
-          <p:nvPr/>
-        </p:nvSpPr>
-        <p:spPr>
-          <a:xfrm>
-            <a:off x="640080" y="1417320"/>
-            <a:ext cx="3453384" cy="3730752"/>
-          </a:xfrm>
-          <a:prstGeom prst="roundRect">
-            <a:avLst>
-              <a:gd name="adj" fmla="val 2118"/>
-            </a:avLst>
-          </a:prstGeom>
-          <a:solidFill>
-            <a:srgbClr val="FFFFFF"/>
-          </a:solidFill>
-          <a:ln w="10160">
-            <a:solidFill>
-              <a:srgbClr val="F1E8FD"/>
-            </a:solidFill>
-            <a:prstDash val="solid"/>
-          </a:ln>
-        </p:spPr>
-      </p:sp>
-      <p:sp>
-        <p:nvSpPr>
-          <p:cNvPr id="14" name="Shape 12"/>
-          <p:cNvSpPr/>
-          <p:nvPr/>
-        </p:nvSpPr>
-        <p:spPr>
-          <a:xfrm>
-            <a:off x="914400" y="1719072"/>
-            <a:ext cx="475488" cy="475488"/>
-          </a:xfrm>
-          <a:prstGeom prst="ellipse">
-            <a:avLst/>
-          </a:prstGeom>
-          <a:solidFill>
-            <a:srgbClr val="B88AF7"/>
-          </a:solidFill>
-          <a:ln/>
-        </p:spPr>
-      </p:sp>
-      <p:sp>
-        <p:nvSpPr>
-          <p:cNvPr id="15" name="Text 13"/>
-          <p:cNvSpPr/>
-          <p:nvPr/>
-        </p:nvSpPr>
-        <p:spPr>
-          <a:xfrm>
-            <a:off x="914400" y="1865376"/>
-            <a:ext cx="475488" cy="118872"/>
-          </a:xfrm>
-          <a:prstGeom prst="rect">
-            <a:avLst/>
-          </a:prstGeom>
-          <a:noFill/>
-          <a:ln/>
-        </p:spPr>
-        <p:txBody>
-          <a:bodyPr wrap="square" lIns="0" tIns="0" rIns="0" bIns="0" rtlCol="0" anchor="ctr"/>
-          <a:lstStyle/>
-          <a:p>
-            <a:pPr algn="ctr" indent="0" marL="0">
-              <a:buNone/>
-            </a:pPr>
-            <a:r>
-              <a:rPr lang="en-US" sz="1000" b="1" dirty="0">
-                <a:solidFill>
-                  <a:srgbClr val="28143F"/>
-                </a:solidFill>
-                <a:latin typeface="Aptos" pitchFamily="34" charset="0"/>
-                <a:ea typeface="Aptos" pitchFamily="34" charset="-122"/>
-                <a:cs typeface="Aptos" pitchFamily="34" charset="-120"/>
-              </a:rPr>
-              <a:t>1</a:t>
-            </a:r>
-            <a:endParaRPr lang="en-US" sz="1000" dirty="0"/>
-          </a:p>
-        </p:txBody>
-      </p:sp>
-      <p:sp>
-        <p:nvSpPr>
-          <p:cNvPr id="16" name="Text 14"/>
-          <p:cNvSpPr/>
-          <p:nvPr/>
-        </p:nvSpPr>
-        <p:spPr>
-          <a:xfrm>
-            <a:off x="1572768" y="1728216"/>
-            <a:ext cx="2246376" cy="438912"/>
-          </a:xfrm>
-          <a:prstGeom prst="rect">
-            <a:avLst/>
-          </a:prstGeom>
-          <a:noFill/>
-          <a:ln/>
-        </p:spPr>
-        <p:txBody>
-          <a:bodyPr wrap="square" lIns="0" tIns="0" rIns="0" bIns="0" rtlCol="0" anchor="ctr">
-            <a:normAutofit/>
-          </a:bodyPr>
-          <a:lstStyle/>
-          <a:p>
-            <a:pPr indent="0" marL="0">
-              <a:buNone/>
-            </a:pPr>
-            <a:r>
-              <a:rPr lang="en-US" sz="2000" b="1" dirty="0">
-                <a:solidFill>
-                  <a:srgbClr val="28143F"/>
-                </a:solidFill>
-                <a:latin typeface="Aptos Display" pitchFamily="34" charset="0"/>
-                <a:ea typeface="Aptos Display" pitchFamily="34" charset="-122"/>
-                <a:cs typeface="Aptos Display" pitchFamily="34" charset="-120"/>
-              </a:rPr>
-              <a:t>Toolkit</a:t>
-            </a:r>
-            <a:endParaRPr lang="en-US" sz="2000" dirty="0"/>
-          </a:p>
-        </p:txBody>
-      </p:sp>
-      <p:sp>
-        <p:nvSpPr>
-          <p:cNvPr id="17" name="Text 15"/>
-          <p:cNvSpPr/>
-          <p:nvPr/>
-        </p:nvSpPr>
-        <p:spPr>
-          <a:xfrm>
-            <a:off x="932688" y="2523744"/>
-            <a:ext cx="2868168" cy="1609344"/>
-          </a:xfrm>
-          <a:prstGeom prst="rect">
-            <a:avLst/>
-          </a:prstGeom>
-          <a:noFill/>
-          <a:ln/>
-        </p:spPr>
-        <p:txBody>
-          <a:bodyPr wrap="square" lIns="0" tIns="0" rIns="0" bIns="0" rtlCol="0" anchor="ctr">
-            <a:normAutofit/>
-          </a:bodyPr>
-          <a:lstStyle/>
-          <a:p>
-            <a:pPr indent="0" marL="0">
-              <a:buNone/>
-            </a:pPr>
-            <a:r>
-              <a:rPr lang="en-US" sz="1520" dirty="0">
-                <a:solidFill>
-                  <a:srgbClr val="251B33"/>
-                </a:solidFill>
-                <a:latin typeface="Aptos" pitchFamily="34" charset="0"/>
-                <a:ea typeface="Aptos" pitchFamily="34" charset="-122"/>
-                <a:cs typeface="Aptos" pitchFamily="34" charset="-120"/>
-              </a:rPr>
-              <a:t>VS Code extension with My Resources and Developer Tools for the development workflow</a:t>
-            </a:r>
-            <a:endParaRPr lang="en-US" sz="1520" dirty="0"/>
-          </a:p>
-        </p:txBody>
-      </p:sp>
-      <p:sp>
-        <p:nvSpPr>
-          <p:cNvPr id="18" name="Shape 16"/>
-          <p:cNvSpPr/>
-          <p:nvPr/>
-        </p:nvSpPr>
-        <p:spPr>
-          <a:xfrm>
-            <a:off x="4367784" y="1417320"/>
-            <a:ext cx="3453384" cy="3730752"/>
-          </a:xfrm>
-          <a:prstGeom prst="roundRect">
-            <a:avLst>
-              <a:gd name="adj" fmla="val 2118"/>
-            </a:avLst>
-          </a:prstGeom>
-          <a:solidFill>
-            <a:srgbClr val="FFFFFF"/>
-          </a:solidFill>
-          <a:ln w="10160">
-            <a:solidFill>
-              <a:srgbClr val="F1E8FD"/>
-            </a:solidFill>
-            <a:prstDash val="solid"/>
-          </a:ln>
-        </p:spPr>
-      </p:sp>
-      <p:sp>
-        <p:nvSpPr>
-          <p:cNvPr id="19" name="Shape 17"/>
-          <p:cNvSpPr/>
-          <p:nvPr/>
-        </p:nvSpPr>
-        <p:spPr>
-          <a:xfrm>
-            <a:off x="4642104" y="1719072"/>
-            <a:ext cx="475488" cy="475488"/>
-          </a:xfrm>
-          <a:prstGeom prst="ellipse">
-            <a:avLst/>
-          </a:prstGeom>
-          <a:solidFill>
-            <a:srgbClr val="FFB454"/>
-          </a:solidFill>
-          <a:ln/>
-        </p:spPr>
-      </p:sp>
-      <p:sp>
-        <p:nvSpPr>
-          <p:cNvPr id="20" name="Text 18"/>
-          <p:cNvSpPr/>
-          <p:nvPr/>
-        </p:nvSpPr>
-        <p:spPr>
-          <a:xfrm>
-            <a:off x="4642104" y="1865376"/>
-            <a:ext cx="475488" cy="118872"/>
-          </a:xfrm>
-          <a:prstGeom prst="rect">
-            <a:avLst/>
-          </a:prstGeom>
-          <a:noFill/>
-          <a:ln/>
-        </p:spPr>
-        <p:txBody>
-          <a:bodyPr wrap="square" lIns="0" tIns="0" rIns="0" bIns="0" rtlCol="0" anchor="ctr"/>
-          <a:lstStyle/>
-          <a:p>
-            <a:pPr algn="ctr" indent="0" marL="0">
-              <a:buNone/>
-            </a:pPr>
-            <a:r>
-              <a:rPr lang="en-US" sz="1000" b="1" dirty="0">
-                <a:solidFill>
-                  <a:srgbClr val="28143F"/>
-                </a:solidFill>
-                <a:latin typeface="Aptos" pitchFamily="34" charset="0"/>
-                <a:ea typeface="Aptos" pitchFamily="34" charset="-122"/>
-                <a:cs typeface="Aptos" pitchFamily="34" charset="-120"/>
-              </a:rPr>
-              <a:t>2</a:t>
-            </a:r>
-            <a:endParaRPr lang="en-US" sz="1000" dirty="0"/>
-          </a:p>
-        </p:txBody>
-      </p:sp>
-      <p:sp>
-        <p:nvSpPr>
-          <p:cNvPr id="21" name="Text 19"/>
-          <p:cNvSpPr/>
-          <p:nvPr/>
-        </p:nvSpPr>
-        <p:spPr>
-          <a:xfrm>
-            <a:off x="5300472" y="1728216"/>
-            <a:ext cx="2246376" cy="438912"/>
-          </a:xfrm>
-          <a:prstGeom prst="rect">
-            <a:avLst/>
-          </a:prstGeom>
-          <a:noFill/>
-          <a:ln/>
-        </p:spPr>
-        <p:txBody>
-          <a:bodyPr wrap="square" lIns="0" tIns="0" rIns="0" bIns="0" rtlCol="0" anchor="ctr">
-            <a:normAutofit/>
-          </a:bodyPr>
-          <a:lstStyle/>
-          <a:p>
-            <a:pPr indent="0" marL="0">
-              <a:buNone/>
-            </a:pPr>
-            <a:r>
-              <a:rPr lang="en-US" sz="2000" b="1" dirty="0">
-                <a:solidFill>
-                  <a:srgbClr val="28143F"/>
-                </a:solidFill>
-                <a:latin typeface="Aptos Display" pitchFamily="34" charset="0"/>
-                <a:ea typeface="Aptos Display" pitchFamily="34" charset="-122"/>
-                <a:cs typeface="Aptos Display" pitchFamily="34" charset="-120"/>
-              </a:rPr>
-              <a:t>Toolbox</a:t>
-            </a:r>
-            <a:endParaRPr lang="en-US" sz="2000" dirty="0"/>
-          </a:p>
-        </p:txBody>
-      </p:sp>
-      <p:sp>
-        <p:nvSpPr>
-          <p:cNvPr id="22" name="Text 20"/>
-          <p:cNvSpPr/>
-          <p:nvPr/>
-        </p:nvSpPr>
-        <p:spPr>
-          <a:xfrm>
-            <a:off x="4660392" y="2523744"/>
-            <a:ext cx="2868168" cy="1609344"/>
-          </a:xfrm>
-          <a:prstGeom prst="rect">
-            <a:avLst/>
-          </a:prstGeom>
-          <a:noFill/>
-          <a:ln/>
-        </p:spPr>
-        <p:txBody>
-          <a:bodyPr wrap="square" lIns="0" tIns="0" rIns="0" bIns="0" rtlCol="0" anchor="ctr">
-            <a:normAutofit/>
-          </a:bodyPr>
-          <a:lstStyle/>
-          <a:p>
-            <a:pPr indent="0" marL="0">
-              <a:buNone/>
-            </a:pPr>
-            <a:r>
-              <a:rPr lang="en-US" sz="1520" dirty="0">
-                <a:solidFill>
-                  <a:srgbClr val="251B33"/>
-                </a:solidFill>
-                <a:latin typeface="Aptos" pitchFamily="34" charset="0"/>
-                <a:ea typeface="Aptos" pitchFamily="34" charset="-122"/>
-                <a:cs typeface="Aptos" pitchFamily="34" charset="-120"/>
-              </a:rPr>
-              <a:t>A managed reusable tool collection behind one MCP‑compatible endpoint</a:t>
-            </a:r>
-            <a:endParaRPr lang="en-US" sz="1520" dirty="0"/>
-          </a:p>
-        </p:txBody>
-      </p:sp>
-      <p:sp>
-        <p:nvSpPr>
-          <p:cNvPr id="23" name="Shape 21"/>
-          <p:cNvSpPr/>
-          <p:nvPr/>
-        </p:nvSpPr>
-        <p:spPr>
-          <a:xfrm>
-            <a:off x="8095488" y="1417320"/>
-            <a:ext cx="3453384" cy="3730752"/>
-          </a:xfrm>
-          <a:prstGeom prst="roundRect">
-            <a:avLst>
-              <a:gd name="adj" fmla="val 2118"/>
-            </a:avLst>
-          </a:prstGeom>
-          <a:solidFill>
-            <a:srgbClr val="FFFFFF"/>
-          </a:solidFill>
-          <a:ln w="10160">
-            <a:solidFill>
-              <a:srgbClr val="F1E8FD"/>
-            </a:solidFill>
-            <a:prstDash val="solid"/>
-          </a:ln>
-        </p:spPr>
-      </p:sp>
-      <p:sp>
-        <p:nvSpPr>
-          <p:cNvPr id="24" name="Shape 22"/>
-          <p:cNvSpPr/>
-          <p:nvPr/>
-        </p:nvSpPr>
-        <p:spPr>
-          <a:xfrm>
-            <a:off x="8369808" y="1719072"/>
-            <a:ext cx="475488" cy="475488"/>
-          </a:xfrm>
-          <a:prstGeom prst="ellipse">
-            <a:avLst/>
-          </a:prstGeom>
-          <a:solidFill>
-            <a:srgbClr val="B88AF7"/>
-          </a:solidFill>
-          <a:ln/>
-        </p:spPr>
-      </p:sp>
-      <p:sp>
-        <p:nvSpPr>
-          <p:cNvPr id="25" name="Text 23"/>
-          <p:cNvSpPr/>
-          <p:nvPr/>
-        </p:nvSpPr>
-        <p:spPr>
-          <a:xfrm>
-            <a:off x="8369808" y="1865376"/>
-            <a:ext cx="475488" cy="118872"/>
-          </a:xfrm>
-          <a:prstGeom prst="rect">
-            <a:avLst/>
-          </a:prstGeom>
-          <a:noFill/>
-          <a:ln/>
-        </p:spPr>
-        <p:txBody>
-          <a:bodyPr wrap="square" lIns="0" tIns="0" rIns="0" bIns="0" rtlCol="0" anchor="ctr"/>
-          <a:lstStyle/>
-          <a:p>
-            <a:pPr algn="ctr" indent="0" marL="0">
-              <a:buNone/>
-            </a:pPr>
-            <a:r>
-              <a:rPr lang="en-US" sz="1000" b="1" dirty="0">
-                <a:solidFill>
-                  <a:srgbClr val="28143F"/>
-                </a:solidFill>
-                <a:latin typeface="Aptos" pitchFamily="34" charset="0"/>
-                <a:ea typeface="Aptos" pitchFamily="34" charset="-122"/>
-                <a:cs typeface="Aptos" pitchFamily="34" charset="-120"/>
-              </a:rPr>
-              <a:t>3</a:t>
-            </a:r>
-            <a:endParaRPr lang="en-US" sz="1000" dirty="0"/>
-          </a:p>
-        </p:txBody>
-      </p:sp>
-      <p:sp>
-        <p:nvSpPr>
-          <p:cNvPr id="26" name="Text 24"/>
-          <p:cNvSpPr/>
-          <p:nvPr/>
-        </p:nvSpPr>
-        <p:spPr>
-          <a:xfrm>
-            <a:off x="9028176" y="1728216"/>
-            <a:ext cx="2246376" cy="438912"/>
-          </a:xfrm>
-          <a:prstGeom prst="rect">
-            <a:avLst/>
-          </a:prstGeom>
-          <a:noFill/>
-          <a:ln/>
-        </p:spPr>
-        <p:txBody>
-          <a:bodyPr wrap="square" lIns="0" tIns="0" rIns="0" bIns="0" rtlCol="0" anchor="ctr">
-            <a:normAutofit/>
-          </a:bodyPr>
-          <a:lstStyle/>
-          <a:p>
-            <a:pPr indent="0" marL="0">
-              <a:buNone/>
-            </a:pPr>
-            <a:r>
-              <a:rPr lang="en-US" sz="2000" b="1" dirty="0">
-                <a:solidFill>
-                  <a:srgbClr val="28143F"/>
-                </a:solidFill>
-                <a:latin typeface="Aptos Display" pitchFamily="34" charset="0"/>
-                <a:ea typeface="Aptos Display" pitchFamily="34" charset="-122"/>
-                <a:cs typeface="Aptos Display" pitchFamily="34" charset="-120"/>
-              </a:rPr>
-              <a:t>Foundry coding skill</a:t>
-            </a:r>
-            <a:endParaRPr lang="en-US" sz="2000" dirty="0"/>
-          </a:p>
-        </p:txBody>
-      </p:sp>
-      <p:sp>
-        <p:nvSpPr>
-          <p:cNvPr id="27" name="Text 25"/>
-          <p:cNvSpPr/>
-          <p:nvPr/>
-        </p:nvSpPr>
-        <p:spPr>
-          <a:xfrm>
-            <a:off x="8388096" y="2523744"/>
-            <a:ext cx="2868168" cy="1609344"/>
-          </a:xfrm>
-          <a:prstGeom prst="rect">
-            <a:avLst/>
-          </a:prstGeom>
-          <a:noFill/>
-          <a:ln/>
-        </p:spPr>
-        <p:txBody>
-          <a:bodyPr wrap="square" lIns="0" tIns="0" rIns="0" bIns="0" rtlCol="0" anchor="ctr">
-            <a:normAutofit/>
-          </a:bodyPr>
-          <a:lstStyle/>
-          <a:p>
-            <a:pPr indent="0" marL="0">
-              <a:buNone/>
-            </a:pPr>
-            <a:r>
-              <a:rPr lang="en-US" sz="1520" dirty="0">
-                <a:solidFill>
-                  <a:srgbClr val="251B33"/>
-                </a:solidFill>
-                <a:latin typeface="Aptos" pitchFamily="34" charset="0"/>
-                <a:ea typeface="Aptos" pitchFamily="34" charset="-122"/>
-                <a:cs typeface="Aptos" pitchFamily="34" charset="-120"/>
-              </a:rPr>
-              <a:t>Reusable guidance used by Copilot or another coding agent during development</a:t>
-            </a:r>
-            <a:endParaRPr lang="en-US" sz="1520" dirty="0"/>
-          </a:p>
-        </p:txBody>
-      </p:sp>
-      <p:sp>
-        <p:nvSpPr>
-          <p:cNvPr id="28" name="Shape 26"/>
-          <p:cNvSpPr/>
-          <p:nvPr/>
-        </p:nvSpPr>
-        <p:spPr>
-          <a:xfrm>
-            <a:off x="1024128" y="5376672"/>
-            <a:ext cx="10104120" cy="621792"/>
-          </a:xfrm>
-          <a:prstGeom prst="roundRect">
-            <a:avLst>
-              <a:gd name="adj" fmla="val 11765"/>
-            </a:avLst>
-          </a:prstGeom>
-          <a:solidFill>
-            <a:srgbClr val="28143F"/>
-          </a:solidFill>
-          <a:ln/>
-        </p:spPr>
-      </p:sp>
-      <p:sp>
-        <p:nvSpPr>
-          <p:cNvPr id="29" name="Text 27"/>
-          <p:cNvSpPr/>
-          <p:nvPr/>
-        </p:nvSpPr>
-        <p:spPr>
-          <a:xfrm>
-            <a:off x="1280160" y="5586984"/>
-            <a:ext cx="1325880" cy="146304"/>
-          </a:xfrm>
-          <a:prstGeom prst="rect">
-            <a:avLst/>
-          </a:prstGeom>
-          <a:noFill/>
-          <a:ln/>
-        </p:spPr>
-        <p:txBody>
-          <a:bodyPr wrap="square" lIns="0" tIns="0" rIns="0" bIns="0" rtlCol="0" anchor="ctr"/>
-          <a:lstStyle/>
-          <a:p>
-            <a:pPr indent="0" marL="0">
-              <a:buNone/>
-            </a:pPr>
-            <a:r>
-              <a:rPr lang="en-US" sz="1000" b="1" spc="140" kern="0" dirty="0">
-                <a:solidFill>
-                  <a:srgbClr val="FFB454"/>
-                </a:solidFill>
-                <a:latin typeface="Aptos" pitchFamily="34" charset="0"/>
-                <a:ea typeface="Aptos" pitchFamily="34" charset="-122"/>
-                <a:cs typeface="Aptos" pitchFamily="34" charset="-120"/>
-              </a:rPr>
-              <a:t>BOUNDARY</a:t>
-            </a:r>
-            <a:endParaRPr lang="en-US" sz="1000" dirty="0"/>
-          </a:p>
-        </p:txBody>
-      </p:sp>
-      <p:sp>
-        <p:nvSpPr>
-          <p:cNvPr id="30" name="Text 28"/>
-          <p:cNvSpPr/>
-          <p:nvPr/>
-        </p:nvSpPr>
-        <p:spPr>
-          <a:xfrm>
-            <a:off x="2743200" y="5541264"/>
-            <a:ext cx="8028432" cy="237744"/>
-          </a:xfrm>
-          <a:prstGeom prst="rect">
-            <a:avLst/>
-          </a:prstGeom>
-          <a:noFill/>
-          <a:ln/>
-        </p:spPr>
-        <p:txBody>
-          <a:bodyPr wrap="square" lIns="0" tIns="0" rIns="0" bIns="0" rtlCol="0" anchor="ctr">
-            <a:normAutofit/>
-          </a:bodyPr>
-          <a:lstStyle/>
-          <a:p>
-            <a:pPr indent="0" marL="0">
-              <a:buNone/>
-            </a:pPr>
-            <a:r>
-              <a:rPr lang="en-US" sz="1420" b="1" dirty="0">
-                <a:solidFill>
-                  <a:srgbClr val="FFFFFF"/>
-                </a:solidFill>
-                <a:latin typeface="Aptos" pitchFamily="34" charset="0"/>
-                <a:ea typeface="Aptos" pitchFamily="34" charset="-122"/>
-                <a:cs typeface="Aptos" pitchFamily="34" charset="-120"/>
-              </a:rPr>
-              <a:t>Discovery is not attachment, approval, authorization, or a runtime capability</a:t>
-            </a:r>
-            <a:endParaRPr lang="en-US" sz="1420" dirty="0"/>
-          </a:p>
-        </p:txBody>
-      </p:sp>
-      <p:sp>
-        <p:nvSpPr>
-          <p:cNvPr id="31" name="Text 29"/>
-          <p:cNvSpPr/>
-          <p:nvPr/>
-        </p:nvSpPr>
-        <p:spPr>
-          <a:xfrm>
-            <a:off x="658368" y="6318504"/>
-            <a:ext cx="10881360" cy="182880"/>
-          </a:xfrm>
-          <a:prstGeom prst="rect">
-            <a:avLst/>
-          </a:prstGeom>
-          <a:noFill/>
-          <a:ln/>
-        </p:spPr>
-        <p:txBody>
-          <a:bodyPr wrap="square" lIns="0" tIns="0" rIns="0" bIns="0" rtlCol="0" anchor="ctr">
-            <a:normAutofit/>
-          </a:bodyPr>
-          <a:lstStyle/>
-          <a:p>
-            <a:pPr indent="0" marL="0">
-              <a:buNone/>
-            </a:pPr>
-            <a:r>
-              <a:rPr lang="en-US" sz="940" dirty="0">
-                <a:solidFill>
-                  <a:srgbClr val="6D5A78"/>
-                </a:solidFill>
-                <a:latin typeface="Aptos" pitchFamily="34" charset="0"/>
-                <a:ea typeface="Aptos" pitchFamily="34" charset="-122"/>
-                <a:cs typeface="Aptos" pitchFamily="34" charset="-120"/>
-              </a:rPr>
-              <a:t>REFERENCE  learn.microsoft.com/azure/foundry/how-to/develop/get-started-projects-visual-studio-code  ·  +2 more in notes</a:t>
-            </a:r>
-            <a:endParaRPr lang="en-US" sz="940" dirty="0"/>
-          </a:p>
-        </p:txBody>
-      </p:sp>
-      <p:sp>
-        <p:nvSpPr>
-          <p:cNvPr id="32" name="Shape 30"/>
-          <p:cNvSpPr/>
-          <p:nvPr/>
-        </p:nvSpPr>
-        <p:spPr>
-          <a:xfrm>
-            <a:off x="0" y="6793992"/>
-            <a:ext cx="12191695" cy="64008"/>
-          </a:xfrm>
-          <a:prstGeom prst="rect">
-            <a:avLst/>
-          </a:prstGeom>
-          <a:solidFill>
-            <a:srgbClr val="B88AF7"/>
-          </a:solidFill>
-          <a:ln/>
-        </p:spPr>
-      </p:sp>
-    </p:spTree>
-  </p:cSld>
-  <p:clrMapOvr>
-    <a:masterClrMapping/>
-  </p:clrMapOvr>
-</p:sld>
-</file>
-
-<file path=ppt/slides/slide3.xml><?xml version="1.0" encoding="utf-8"?>
 <p:sld xmlns:a="http://schemas.openxmlformats.org/drawingml/2006/main" xmlns:r="http://schemas.openxmlformats.org/officeDocument/2006/relationships" xmlns:p="http://schemas.openxmlformats.org/presentationml/2006/main">
   <p:cSld name="Slide 3">
     <p:bg>
@@ -2985,7 +2080,7 @@
                 <a:ea typeface="Aptos Display" pitchFamily="34" charset="-122"/>
                 <a:cs typeface="Aptos Display" pitchFamily="34" charset="-120"/>
               </a:rPr>
-              <a:t>Name the object before choosing the view</a:t>
+              <a:t>Toolkit, Toolbox, and coding skills</a:t>
             </a:r>
             <a:endParaRPr lang="en-US" sz="3100" dirty="0"/>
           </a:p>
@@ -3195,11 +2290,11 @@
         <p:spPr>
           <a:xfrm>
             <a:off x="640080" y="1417320"/>
-            <a:ext cx="6400800" cy="4645152"/>
+            <a:ext cx="3453384" cy="3730752"/>
           </a:xfrm>
           <a:prstGeom prst="roundRect">
             <a:avLst>
-              <a:gd name="adj" fmla="val 1575"/>
+              <a:gd name="adj" fmla="val 2118"/>
             </a:avLst>
           </a:prstGeom>
           <a:solidFill>
@@ -3215,14 +2310,34 @@
       </p:sp>
       <p:sp>
         <p:nvSpPr>
-          <p:cNvPr id="14" name="Text 12"/>
-          <p:cNvSpPr/>
-          <p:nvPr/>
-        </p:nvSpPr>
-        <p:spPr>
-          <a:xfrm>
-            <a:off x="941832" y="1737360"/>
-            <a:ext cx="2286000" cy="164592"/>
+          <p:cNvPr id="14" name="Shape 12"/>
+          <p:cNvSpPr/>
+          <p:nvPr/>
+        </p:nvSpPr>
+        <p:spPr>
+          <a:xfrm>
+            <a:off x="914400" y="1719072"/>
+            <a:ext cx="475488" cy="475488"/>
+          </a:xfrm>
+          <a:prstGeom prst="ellipse">
+            <a:avLst/>
+          </a:prstGeom>
+          <a:solidFill>
+            <a:srgbClr val="B88AF7"/>
+          </a:solidFill>
+          <a:ln/>
+        </p:spPr>
+      </p:sp>
+      <p:sp>
+        <p:nvSpPr>
+          <p:cNvPr id="15" name="Text 13"/>
+          <p:cNvSpPr/>
+          <p:nvPr/>
+        </p:nvSpPr>
+        <p:spPr>
+          <a:xfrm>
+            <a:off x="914400" y="1865376"/>
+            <a:ext cx="475488" cy="118872"/>
           </a:xfrm>
           <a:prstGeom prst="rect">
             <a:avLst/>
@@ -3234,46 +2349,128 @@
           <a:bodyPr wrap="square" lIns="0" tIns="0" rIns="0" bIns="0" rtlCol="0" anchor="ctr"/>
           <a:lstStyle/>
           <a:p>
+            <a:pPr algn="ctr" indent="0" marL="0">
+              <a:buNone/>
+            </a:pPr>
+            <a:r>
+              <a:rPr lang="en-US" sz="1000" b="1" dirty="0">
+                <a:solidFill>
+                  <a:srgbClr val="28143F"/>
+                </a:solidFill>
+                <a:latin typeface="Aptos" pitchFamily="34" charset="0"/>
+                <a:ea typeface="Aptos" pitchFamily="34" charset="-122"/>
+                <a:cs typeface="Aptos" pitchFamily="34" charset="-120"/>
+              </a:rPr>
+              <a:t>1</a:t>
+            </a:r>
+            <a:endParaRPr lang="en-US" sz="1000" dirty="0"/>
+          </a:p>
+        </p:txBody>
+      </p:sp>
+      <p:sp>
+        <p:nvSpPr>
+          <p:cNvPr id="16" name="Text 14"/>
+          <p:cNvSpPr/>
+          <p:nvPr/>
+        </p:nvSpPr>
+        <p:spPr>
+          <a:xfrm>
+            <a:off x="1572768" y="1728216"/>
+            <a:ext cx="2246376" cy="438912"/>
+          </a:xfrm>
+          <a:prstGeom prst="rect">
+            <a:avLst/>
+          </a:prstGeom>
+          <a:noFill/>
+          <a:ln/>
+        </p:spPr>
+        <p:txBody>
+          <a:bodyPr wrap="square" lIns="0" tIns="0" rIns="0" bIns="0" rtlCol="0" anchor="ctr">
+            <a:normAutofit/>
+          </a:bodyPr>
+          <a:lstStyle/>
+          <a:p>
             <a:pPr indent="0" marL="0">
               <a:buNone/>
             </a:pPr>
             <a:r>
-              <a:rPr lang="en-US" sz="1000" b="1" spc="210" kern="0" dirty="0">
+              <a:rPr lang="en-US" sz="2000" b="1" dirty="0">
                 <a:solidFill>
                   <a:srgbClr val="28143F"/>
                 </a:solidFill>
-                <a:latin typeface="Aptos" pitchFamily="34" charset="0"/>
-                <a:ea typeface="Aptos" pitchFamily="34" charset="-122"/>
-                <a:cs typeface="Aptos" pitchFamily="34" charset="-120"/>
-              </a:rPr>
-              <a:t>RUNTIME OBJECTS</a:t>
-            </a:r>
-            <a:endParaRPr lang="en-US" sz="1000" dirty="0"/>
-          </a:p>
-        </p:txBody>
-      </p:sp>
-      <p:sp>
-        <p:nvSpPr>
-          <p:cNvPr id="15" name="Shape 13"/>
-          <p:cNvSpPr/>
-          <p:nvPr/>
-        </p:nvSpPr>
-        <p:spPr>
-          <a:xfrm>
-            <a:off x="1024128" y="2121408"/>
-            <a:ext cx="5596128" cy="2578608"/>
+                <a:latin typeface="Aptos Display" pitchFamily="34" charset="0"/>
+                <a:ea typeface="Aptos Display" pitchFamily="34" charset="-122"/>
+                <a:cs typeface="Aptos Display" pitchFamily="34" charset="-120"/>
+              </a:rPr>
+              <a:t>Toolkit</a:t>
+            </a:r>
+            <a:endParaRPr lang="en-US" sz="2000" dirty="0"/>
+          </a:p>
+        </p:txBody>
+      </p:sp>
+      <p:sp>
+        <p:nvSpPr>
+          <p:cNvPr id="17" name="Text 15"/>
+          <p:cNvSpPr/>
+          <p:nvPr/>
+        </p:nvSpPr>
+        <p:spPr>
+          <a:xfrm>
+            <a:off x="932688" y="2523744"/>
+            <a:ext cx="2868168" cy="1609344"/>
+          </a:xfrm>
+          <a:prstGeom prst="rect">
+            <a:avLst/>
+          </a:prstGeom>
+          <a:noFill/>
+          <a:ln/>
+        </p:spPr>
+        <p:txBody>
+          <a:bodyPr wrap="square" lIns="0" tIns="0" rIns="0" bIns="0" rtlCol="0" anchor="ctr">
+            <a:normAutofit/>
+          </a:bodyPr>
+          <a:lstStyle/>
+          <a:p>
+            <a:pPr indent="0" marL="0">
+              <a:buNone/>
+            </a:pPr>
+            <a:r>
+              <a:rPr lang="en-US" sz="1520" dirty="0">
+                <a:solidFill>
+                  <a:srgbClr val="251B33"/>
+                </a:solidFill>
+                <a:latin typeface="Aptos" pitchFamily="34" charset="0"/>
+                <a:ea typeface="Aptos" pitchFamily="34" charset="-122"/>
+                <a:cs typeface="Aptos" pitchFamily="34" charset="-120"/>
+              </a:rPr>
+              <a:t>VS Code extension with My Resources and Developer Tools for the development workflow</a:t>
+            </a:r>
+            <a:endParaRPr lang="en-US" sz="1520" dirty="0"/>
+          </a:p>
+        </p:txBody>
+      </p:sp>
+      <p:sp>
+        <p:nvSpPr>
+          <p:cNvPr id="18" name="Shape 16"/>
+          <p:cNvSpPr/>
+          <p:nvPr/>
+        </p:nvSpPr>
+        <p:spPr>
+          <a:xfrm>
+            <a:off x="4367784" y="1417320"/>
+            <a:ext cx="3453384" cy="3730752"/>
           </a:xfrm>
           <a:prstGeom prst="roundRect">
             <a:avLst>
-              <a:gd name="adj" fmla="val 2837"/>
+              <a:gd name="adj" fmla="val 2118"/>
             </a:avLst>
           </a:prstGeom>
           <a:solidFill>
-            <a:srgbClr val="F1E8FD"/>
+            <a:srgbClr val="FFFFFF"/>
           </a:solidFill>
           <a:ln w="10160">
             <a:solidFill>
-              <a:srgbClr val="B88AF7"/>
+              <a:srgbClr val="F1E8FD"/>
             </a:solidFill>
             <a:prstDash val="solid"/>
           </a:ln>
@@ -3281,14 +2478,34 @@
       </p:sp>
       <p:sp>
         <p:nvSpPr>
-          <p:cNvPr id="16" name="Text 14"/>
-          <p:cNvSpPr/>
-          <p:nvPr/>
-        </p:nvSpPr>
-        <p:spPr>
-          <a:xfrm>
-            <a:off x="1325880" y="2423160"/>
-            <a:ext cx="1325880" cy="164592"/>
+          <p:cNvPr id="19" name="Shape 17"/>
+          <p:cNvSpPr/>
+          <p:nvPr/>
+        </p:nvSpPr>
+        <p:spPr>
+          <a:xfrm>
+            <a:off x="4642104" y="1719072"/>
+            <a:ext cx="475488" cy="475488"/>
+          </a:xfrm>
+          <a:prstGeom prst="ellipse">
+            <a:avLst/>
+          </a:prstGeom>
+          <a:solidFill>
+            <a:srgbClr val="FFB454"/>
+          </a:solidFill>
+          <a:ln/>
+        </p:spPr>
+      </p:sp>
+      <p:sp>
+        <p:nvSpPr>
+          <p:cNvPr id="20" name="Text 18"/>
+          <p:cNvSpPr/>
+          <p:nvPr/>
+        </p:nvSpPr>
+        <p:spPr>
+          <a:xfrm>
+            <a:off x="4642104" y="1865376"/>
+            <a:ext cx="475488" cy="118872"/>
           </a:xfrm>
           <a:prstGeom prst="rect">
             <a:avLst/>
@@ -3300,11 +2517,11 @@
           <a:bodyPr wrap="square" lIns="0" tIns="0" rIns="0" bIns="0" rtlCol="0" anchor="ctr"/>
           <a:lstStyle/>
           <a:p>
-            <a:pPr indent="0" marL="0">
-              <a:buNone/>
-            </a:pPr>
-            <a:r>
-              <a:rPr lang="en-US" sz="1100" b="1" spc="170" kern="0" dirty="0">
+            <a:pPr algn="ctr" indent="0" marL="0">
+              <a:buNone/>
+            </a:pPr>
+            <a:r>
+              <a:rPr lang="en-US" sz="1000" b="1" dirty="0">
                 <a:solidFill>
                   <a:srgbClr val="28143F"/>
                 </a:solidFill>
@@ -3312,22 +2529,22 @@
                 <a:ea typeface="Aptos" pitchFamily="34" charset="-122"/>
                 <a:cs typeface="Aptos" pitchFamily="34" charset="-120"/>
               </a:rPr>
-              <a:t>AGENT</a:t>
-            </a:r>
-            <a:endParaRPr lang="en-US" sz="1100" dirty="0"/>
-          </a:p>
-        </p:txBody>
-      </p:sp>
-      <p:sp>
-        <p:nvSpPr>
-          <p:cNvPr id="17" name="Text 15"/>
-          <p:cNvSpPr/>
-          <p:nvPr/>
-        </p:nvSpPr>
-        <p:spPr>
-          <a:xfrm>
-            <a:off x="1325880" y="2834640"/>
-            <a:ext cx="2304288" cy="1078992"/>
+              <a:t>2</a:t>
+            </a:r>
+            <a:endParaRPr lang="en-US" sz="1000" dirty="0"/>
+          </a:p>
+        </p:txBody>
+      </p:sp>
+      <p:sp>
+        <p:nvSpPr>
+          <p:cNvPr id="21" name="Text 19"/>
+          <p:cNvSpPr/>
+          <p:nvPr/>
+        </p:nvSpPr>
+        <p:spPr>
+          <a:xfrm>
+            <a:off x="5300472" y="1728216"/>
+            <a:ext cx="2246376" cy="438912"/>
           </a:xfrm>
           <a:prstGeom prst="rect">
             <a:avLst/>
@@ -3345,7 +2562,48 @@
               <a:buNone/>
             </a:pPr>
             <a:r>
-              <a:rPr lang="en-US" sz="1430" dirty="0">
+              <a:rPr lang="en-US" sz="2000" b="1" dirty="0">
+                <a:solidFill>
+                  <a:srgbClr val="28143F"/>
+                </a:solidFill>
+                <a:latin typeface="Aptos Display" pitchFamily="34" charset="0"/>
+                <a:ea typeface="Aptos Display" pitchFamily="34" charset="-122"/>
+                <a:cs typeface="Aptos Display" pitchFamily="34" charset="-120"/>
+              </a:rPr>
+              <a:t>Toolbox</a:t>
+            </a:r>
+            <a:endParaRPr lang="en-US" sz="2000" dirty="0"/>
+          </a:p>
+        </p:txBody>
+      </p:sp>
+      <p:sp>
+        <p:nvSpPr>
+          <p:cNvPr id="22" name="Text 20"/>
+          <p:cNvSpPr/>
+          <p:nvPr/>
+        </p:nvSpPr>
+        <p:spPr>
+          <a:xfrm>
+            <a:off x="4660392" y="2523744"/>
+            <a:ext cx="2868168" cy="1609344"/>
+          </a:xfrm>
+          <a:prstGeom prst="rect">
+            <a:avLst/>
+          </a:prstGeom>
+          <a:noFill/>
+          <a:ln/>
+        </p:spPr>
+        <p:txBody>
+          <a:bodyPr wrap="square" lIns="0" tIns="0" rIns="0" bIns="0" rtlCol="0" anchor="ctr">
+            <a:normAutofit/>
+          </a:bodyPr>
+          <a:lstStyle/>
+          <a:p>
+            <a:pPr indent="0" marL="0">
+              <a:buNone/>
+            </a:pPr>
+            <a:r>
+              <a:rPr lang="en-US" sz="1520" dirty="0">
                 <a:solidFill>
                   <a:srgbClr val="251B33"/>
                 </a:solidFill>
@@ -3353,26 +2611,26 @@
                 <a:ea typeface="Aptos" pitchFamily="34" charset="-122"/>
                 <a:cs typeface="Aptos" pitchFamily="34" charset="-120"/>
               </a:rPr>
-              <a:t>Combines model-driven behavior with instructions and tools</a:t>
-            </a:r>
-            <a:endParaRPr lang="en-US" sz="1430" dirty="0"/>
-          </a:p>
-        </p:txBody>
-      </p:sp>
-      <p:sp>
-        <p:nvSpPr>
-          <p:cNvPr id="18" name="Shape 16"/>
-          <p:cNvSpPr/>
-          <p:nvPr/>
-        </p:nvSpPr>
-        <p:spPr>
-          <a:xfrm>
-            <a:off x="3886200" y="2468880"/>
-            <a:ext cx="2331720" cy="1691640"/>
+              <a:t>A managed reusable tool collection behind one MCP‑compatible endpoint</a:t>
+            </a:r>
+            <a:endParaRPr lang="en-US" sz="1520" dirty="0"/>
+          </a:p>
+        </p:txBody>
+      </p:sp>
+      <p:sp>
+        <p:nvSpPr>
+          <p:cNvPr id="23" name="Shape 21"/>
+          <p:cNvSpPr/>
+          <p:nvPr/>
+        </p:nvSpPr>
+        <p:spPr>
+          <a:xfrm>
+            <a:off x="8095488" y="1417320"/>
+            <a:ext cx="3453384" cy="3730752"/>
           </a:xfrm>
           <a:prstGeom prst="roundRect">
             <a:avLst>
-              <a:gd name="adj" fmla="val 4324"/>
+              <a:gd name="adj" fmla="val 2118"/>
             </a:avLst>
           </a:prstGeom>
           <a:solidFill>
@@ -3380,7 +2638,7 @@
           </a:solidFill>
           <a:ln w="10160">
             <a:solidFill>
-              <a:srgbClr val="FFB454"/>
+              <a:srgbClr val="F1E8FD"/>
             </a:solidFill>
             <a:prstDash val="solid"/>
           </a:ln>
@@ -3388,14 +2646,34 @@
       </p:sp>
       <p:sp>
         <p:nvSpPr>
-          <p:cNvPr id="19" name="Text 17"/>
-          <p:cNvSpPr/>
-          <p:nvPr/>
-        </p:nvSpPr>
-        <p:spPr>
-          <a:xfrm>
-            <a:off x="4160520" y="2743200"/>
-            <a:ext cx="1783080" cy="164592"/>
+          <p:cNvPr id="24" name="Shape 22"/>
+          <p:cNvSpPr/>
+          <p:nvPr/>
+        </p:nvSpPr>
+        <p:spPr>
+          <a:xfrm>
+            <a:off x="8369808" y="1719072"/>
+            <a:ext cx="475488" cy="475488"/>
+          </a:xfrm>
+          <a:prstGeom prst="ellipse">
+            <a:avLst/>
+          </a:prstGeom>
+          <a:solidFill>
+            <a:srgbClr val="B88AF7"/>
+          </a:solidFill>
+          <a:ln/>
+        </p:spPr>
+      </p:sp>
+      <p:sp>
+        <p:nvSpPr>
+          <p:cNvPr id="25" name="Text 23"/>
+          <p:cNvSpPr/>
+          <p:nvPr/>
+        </p:nvSpPr>
+        <p:spPr>
+          <a:xfrm>
+            <a:off x="8369808" y="1865376"/>
+            <a:ext cx="475488" cy="118872"/>
           </a:xfrm>
           <a:prstGeom prst="rect">
             <a:avLst/>
@@ -3411,7 +2689,7 @@
               <a:buNone/>
             </a:pPr>
             <a:r>
-              <a:rPr lang="en-US" sz="1100" b="1" spc="170" kern="0" dirty="0">
+              <a:rPr lang="en-US" sz="1000" b="1" dirty="0">
                 <a:solidFill>
                   <a:srgbClr val="28143F"/>
                 </a:solidFill>
@@ -3419,22 +2697,22 @@
                 <a:ea typeface="Aptos" pitchFamily="34" charset="-122"/>
                 <a:cs typeface="Aptos" pitchFamily="34" charset="-120"/>
               </a:rPr>
-              <a:t>MODEL</a:t>
-            </a:r>
-            <a:endParaRPr lang="en-US" sz="1100" dirty="0"/>
-          </a:p>
-        </p:txBody>
-      </p:sp>
-      <p:sp>
-        <p:nvSpPr>
-          <p:cNvPr id="20" name="Text 18"/>
-          <p:cNvSpPr/>
-          <p:nvPr/>
-        </p:nvSpPr>
-        <p:spPr>
-          <a:xfrm>
-            <a:off x="4187952" y="3182112"/>
-            <a:ext cx="1728216" cy="566928"/>
+              <a:t>3</a:t>
+            </a:r>
+            <a:endParaRPr lang="en-US" sz="1000" dirty="0"/>
+          </a:p>
+        </p:txBody>
+      </p:sp>
+      <p:sp>
+        <p:nvSpPr>
+          <p:cNvPr id="26" name="Text 24"/>
+          <p:cNvSpPr/>
+          <p:nvPr/>
+        </p:nvSpPr>
+        <p:spPr>
+          <a:xfrm>
+            <a:off x="9028176" y="1728216"/>
+            <a:ext cx="2246376" cy="438912"/>
           </a:xfrm>
           <a:prstGeom prst="rect">
             <a:avLst/>
@@ -3448,123 +2726,34 @@
           </a:bodyPr>
           <a:lstStyle/>
           <a:p>
-            <a:pPr algn="ctr" indent="0" marL="0">
-              <a:buNone/>
-            </a:pPr>
-            <a:r>
-              <a:rPr lang="en-US" sz="1370" dirty="0">
-                <a:solidFill>
-                  <a:srgbClr val="251B33"/>
-                </a:solidFill>
-                <a:latin typeface="Aptos" pitchFamily="34" charset="0"/>
-                <a:ea typeface="Aptos" pitchFamily="34" charset="-122"/>
-                <a:cs typeface="Aptos" pitchFamily="34" charset="-120"/>
-              </a:rPr>
-              <a:t>Performs inference for a prompt and selected parameters</a:t>
-            </a:r>
-            <a:endParaRPr lang="en-US" sz="1370" dirty="0"/>
-          </a:p>
-        </p:txBody>
-      </p:sp>
-      <p:sp>
-        <p:nvSpPr>
-          <p:cNvPr id="21" name="Shape 19"/>
-          <p:cNvSpPr/>
-          <p:nvPr/>
-        </p:nvSpPr>
-        <p:spPr>
-          <a:xfrm>
-            <a:off x="3730752" y="4700016"/>
-            <a:ext cx="0" cy="310896"/>
-          </a:xfrm>
-          <a:prstGeom prst="line">
-            <a:avLst/>
-          </a:prstGeom>
-          <a:noFill/>
-          <a:ln w="25400">
-            <a:solidFill>
-              <a:srgbClr val="B88AF7"/>
-            </a:solidFill>
-            <a:prstDash val="solid"/>
-          </a:ln>
-        </p:spPr>
-      </p:sp>
-      <p:sp>
-        <p:nvSpPr>
-          <p:cNvPr id="22" name="Shape 20"/>
-          <p:cNvSpPr/>
-          <p:nvPr/>
-        </p:nvSpPr>
-        <p:spPr>
-          <a:xfrm>
-            <a:off x="1024128" y="5010912"/>
-            <a:ext cx="5596128" cy="749808"/>
-          </a:xfrm>
-          <a:prstGeom prst="roundRect">
-            <a:avLst>
-              <a:gd name="adj" fmla="val 9756"/>
-            </a:avLst>
-          </a:prstGeom>
-          <a:solidFill>
-            <a:srgbClr val="FFF1D9"/>
-          </a:solidFill>
-          <a:ln w="10160">
-            <a:solidFill>
-              <a:srgbClr val="FFB454"/>
-            </a:solidFill>
-            <a:prstDash val="solid"/>
-          </a:ln>
-        </p:spPr>
-      </p:sp>
-      <p:sp>
-        <p:nvSpPr>
-          <p:cNvPr id="23" name="Text 21"/>
-          <p:cNvSpPr/>
-          <p:nvPr/>
-        </p:nvSpPr>
-        <p:spPr>
-          <a:xfrm>
-            <a:off x="1298448" y="5266944"/>
-            <a:ext cx="1417320" cy="155448"/>
-          </a:xfrm>
-          <a:prstGeom prst="rect">
-            <a:avLst/>
-          </a:prstGeom>
-          <a:noFill/>
-          <a:ln/>
-        </p:spPr>
-        <p:txBody>
-          <a:bodyPr wrap="square" lIns="0" tIns="0" rIns="0" bIns="0" rtlCol="0" anchor="ctr"/>
-          <a:lstStyle/>
-          <a:p>
             <a:pPr indent="0" marL="0">
               <a:buNone/>
             </a:pPr>
             <a:r>
-              <a:rPr lang="en-US" sz="1050" b="1" spc="140" kern="0" dirty="0">
+              <a:rPr lang="en-US" sz="2000" b="1" dirty="0">
                 <a:solidFill>
                   <a:srgbClr val="28143F"/>
                 </a:solidFill>
-                <a:latin typeface="Aptos" pitchFamily="34" charset="0"/>
-                <a:ea typeface="Aptos" pitchFamily="34" charset="-122"/>
-                <a:cs typeface="Aptos" pitchFamily="34" charset="-120"/>
-              </a:rPr>
-              <a:t>CONVERSATION</a:t>
-            </a:r>
-            <a:endParaRPr lang="en-US" sz="1050" dirty="0"/>
-          </a:p>
-        </p:txBody>
-      </p:sp>
-      <p:sp>
-        <p:nvSpPr>
-          <p:cNvPr id="24" name="Text 22"/>
-          <p:cNvSpPr/>
-          <p:nvPr/>
-        </p:nvSpPr>
-        <p:spPr>
-          <a:xfrm>
-            <a:off x="2816352" y="5212080"/>
-            <a:ext cx="3447288" cy="256032"/>
+                <a:latin typeface="Aptos Display" pitchFamily="34" charset="0"/>
+                <a:ea typeface="Aptos Display" pitchFamily="34" charset="-122"/>
+                <a:cs typeface="Aptos Display" pitchFamily="34" charset="-120"/>
+              </a:rPr>
+              <a:t>Foundry coding skill</a:t>
+            </a:r>
+            <a:endParaRPr lang="en-US" sz="2000" dirty="0"/>
+          </a:p>
+        </p:txBody>
+      </p:sp>
+      <p:sp>
+        <p:nvSpPr>
+          <p:cNvPr id="27" name="Text 25"/>
+          <p:cNvSpPr/>
+          <p:nvPr/>
+        </p:nvSpPr>
+        <p:spPr>
+          <a:xfrm>
+            <a:off x="8388096" y="2523744"/>
+            <a:ext cx="2868168" cy="1609344"/>
           </a:xfrm>
           <a:prstGeom prst="rect">
             <a:avLst/>
@@ -3582,7 +2771,7 @@
               <a:buNone/>
             </a:pPr>
             <a:r>
-              <a:rPr lang="en-US" sz="1400" b="1" dirty="0">
+              <a:rPr lang="en-US" sz="1520" dirty="0">
                 <a:solidFill>
                   <a:srgbClr val="251B33"/>
                 </a:solidFill>
@@ -3590,49 +2779,83 @@
                 <a:ea typeface="Aptos" pitchFamily="34" charset="-122"/>
                 <a:cs typeface="Aptos" pitchFamily="34" charset="-120"/>
               </a:rPr>
-              <a:t>Persists dialogue history across turns</a:t>
-            </a:r>
-            <a:endParaRPr lang="en-US" sz="1400" dirty="0"/>
-          </a:p>
-        </p:txBody>
-      </p:sp>
-      <p:sp>
-        <p:nvSpPr>
-          <p:cNvPr id="25" name="Shape 23"/>
-          <p:cNvSpPr/>
-          <p:nvPr/>
-        </p:nvSpPr>
-        <p:spPr>
-          <a:xfrm>
-            <a:off x="7269480" y="1417320"/>
-            <a:ext cx="4279392" cy="4645152"/>
+              <a:t>Reusable guidance used by Copilot or another coding agent during development</a:t>
+            </a:r>
+            <a:endParaRPr lang="en-US" sz="1520" dirty="0"/>
+          </a:p>
+        </p:txBody>
+      </p:sp>
+      <p:sp>
+        <p:nvSpPr>
+          <p:cNvPr id="28" name="Shape 26"/>
+          <p:cNvSpPr/>
+          <p:nvPr/>
+        </p:nvSpPr>
+        <p:spPr>
+          <a:xfrm>
+            <a:off x="1024128" y="5376672"/>
+            <a:ext cx="10104120" cy="621792"/>
           </a:xfrm>
           <a:prstGeom prst="roundRect">
             <a:avLst>
-              <a:gd name="adj" fmla="val 1709"/>
+              <a:gd name="adj" fmla="val 11765"/>
             </a:avLst>
           </a:prstGeom>
           <a:solidFill>
-            <a:srgbClr val="F1E8FD"/>
-          </a:solidFill>
-          <a:ln w="10160">
-            <a:solidFill>
-              <a:srgbClr val="B88AF7"/>
-            </a:solidFill>
-            <a:prstDash val="solid"/>
-          </a:ln>
-        </p:spPr>
-      </p:sp>
-      <p:sp>
-        <p:nvSpPr>
-          <p:cNvPr id="26" name="Text 24"/>
-          <p:cNvSpPr/>
-          <p:nvPr/>
-        </p:nvSpPr>
-        <p:spPr>
-          <a:xfrm>
-            <a:off x="7562088" y="1755648"/>
-            <a:ext cx="3401568" cy="173736"/>
+            <a:srgbClr val="28143F"/>
+          </a:solidFill>
+          <a:ln/>
+        </p:spPr>
+      </p:sp>
+      <p:sp>
+        <p:nvSpPr>
+          <p:cNvPr id="29" name="Text 27"/>
+          <p:cNvSpPr/>
+          <p:nvPr/>
+        </p:nvSpPr>
+        <p:spPr>
+          <a:xfrm>
+            <a:off x="1280160" y="5586984"/>
+            <a:ext cx="1325880" cy="146304"/>
+          </a:xfrm>
+          <a:prstGeom prst="rect">
+            <a:avLst/>
+          </a:prstGeom>
+          <a:noFill/>
+          <a:ln/>
+        </p:spPr>
+        <p:txBody>
+          <a:bodyPr wrap="square" lIns="0" tIns="0" rIns="0" bIns="0" rtlCol="0" anchor="ctr"/>
+          <a:lstStyle/>
+          <a:p>
+            <a:pPr indent="0" marL="0">
+              <a:buNone/>
+            </a:pPr>
+            <a:r>
+              <a:rPr lang="en-US" sz="1000" b="1" spc="140" kern="0" dirty="0">
+                <a:solidFill>
+                  <a:srgbClr val="FFB454"/>
+                </a:solidFill>
+                <a:latin typeface="Aptos" pitchFamily="34" charset="0"/>
+                <a:ea typeface="Aptos" pitchFamily="34" charset="-122"/>
+                <a:cs typeface="Aptos" pitchFamily="34" charset="-120"/>
+              </a:rPr>
+              <a:t>BOUNDARY</a:t>
+            </a:r>
+            <a:endParaRPr lang="en-US" sz="1000" dirty="0"/>
+          </a:p>
+        </p:txBody>
+      </p:sp>
+      <p:sp>
+        <p:nvSpPr>
+          <p:cNvPr id="30" name="Text 28"/>
+          <p:cNvSpPr/>
+          <p:nvPr/>
+        </p:nvSpPr>
+        <p:spPr>
+          <a:xfrm>
+            <a:off x="2743200" y="5541264"/>
+            <a:ext cx="8028432" cy="237744"/>
           </a:xfrm>
           <a:prstGeom prst="rect">
             <a:avLst/>
@@ -3650,91 +2873,30 @@
               <a:buNone/>
             </a:pPr>
             <a:r>
-              <a:rPr lang="en-US" sz="920" b="1" spc="120" kern="0" dirty="0">
-                <a:solidFill>
-                  <a:srgbClr val="28143F"/>
-                </a:solidFill>
-                <a:latin typeface="Aptos" pitchFamily="34" charset="0"/>
-                <a:ea typeface="Aptos" pitchFamily="34" charset="-122"/>
-                <a:cs typeface="Aptos" pitchFamily="34" charset="-120"/>
-              </a:rPr>
-              <a:t>STORAGE BADGE · CONFIGURATION LOCATION</a:t>
-            </a:r>
-            <a:endParaRPr lang="en-US" sz="920" dirty="0"/>
-          </a:p>
-        </p:txBody>
-      </p:sp>
-      <p:sp>
-        <p:nvSpPr>
-          <p:cNvPr id="27" name="Shape 25"/>
-          <p:cNvSpPr/>
-          <p:nvPr/>
-        </p:nvSpPr>
-        <p:spPr>
-          <a:xfrm>
-            <a:off x="7589520" y="2286000"/>
-            <a:ext cx="3639312" cy="676656"/>
-          </a:xfrm>
-          <a:prstGeom prst="roundRect">
-            <a:avLst>
-              <a:gd name="adj" fmla="val 10811"/>
-            </a:avLst>
-          </a:prstGeom>
-          <a:solidFill>
-            <a:srgbClr val="B88AF7"/>
-          </a:solidFill>
-          <a:ln/>
-        </p:spPr>
-      </p:sp>
-      <p:sp>
-        <p:nvSpPr>
-          <p:cNvPr id="28" name="Text 26"/>
-          <p:cNvSpPr/>
-          <p:nvPr/>
-        </p:nvSpPr>
-        <p:spPr>
-          <a:xfrm>
-            <a:off x="7900416" y="2514600"/>
-            <a:ext cx="3017520" cy="155448"/>
-          </a:xfrm>
-          <a:prstGeom prst="rect">
-            <a:avLst/>
-          </a:prstGeom>
-          <a:noFill/>
-          <a:ln/>
-        </p:spPr>
-        <p:txBody>
-          <a:bodyPr wrap="square" lIns="0" tIns="0" rIns="0" bIns="0" rtlCol="0" anchor="ctr"/>
-          <a:lstStyle/>
-          <a:p>
-            <a:pPr algn="ctr" indent="0" marL="0">
-              <a:buNone/>
-            </a:pPr>
-            <a:r>
-              <a:rPr lang="en-US" sz="1700" b="1" dirty="0">
-                <a:solidFill>
-                  <a:srgbClr val="28143F"/>
-                </a:solidFill>
-                <a:latin typeface="Aptos" pitchFamily="34" charset="0"/>
-                <a:ea typeface="Aptos" pitchFamily="34" charset="-122"/>
-                <a:cs typeface="Aptos" pitchFamily="34" charset="-120"/>
-              </a:rPr>
-              <a:t>LOCAL</a:t>
-            </a:r>
-            <a:endParaRPr lang="en-US" sz="1700" dirty="0"/>
-          </a:p>
-        </p:txBody>
-      </p:sp>
-      <p:sp>
-        <p:nvSpPr>
-          <p:cNvPr id="29" name="Text 27"/>
-          <p:cNvSpPr/>
-          <p:nvPr/>
-        </p:nvSpPr>
-        <p:spPr>
-          <a:xfrm>
-            <a:off x="7635240" y="3310128"/>
-            <a:ext cx="3547872" cy="841248"/>
+              <a:rPr lang="en-US" sz="1420" b="1" dirty="0">
+                <a:solidFill>
+                  <a:srgbClr val="FFFFFF"/>
+                </a:solidFill>
+                <a:latin typeface="Aptos" pitchFamily="34" charset="0"/>
+                <a:ea typeface="Aptos" pitchFamily="34" charset="-122"/>
+                <a:cs typeface="Aptos" pitchFamily="34" charset="-120"/>
+              </a:rPr>
+              <a:t>Discovery is not attachment, approval, authorization, or a runtime capability</a:t>
+            </a:r>
+            <a:endParaRPr lang="en-US" sz="1420" dirty="0"/>
+          </a:p>
+        </p:txBody>
+      </p:sp>
+      <p:sp>
+        <p:nvSpPr>
+          <p:cNvPr id="31" name="Text 29"/>
+          <p:cNvSpPr/>
+          <p:nvPr/>
+        </p:nvSpPr>
+        <p:spPr>
+          <a:xfrm>
+            <a:off x="658368" y="6318504"/>
+            <a:ext cx="10881360" cy="182880"/>
           </a:xfrm>
           <a:prstGeom prst="rect">
             <a:avLst/>
@@ -3748,110 +2910,6 @@
           </a:bodyPr>
           <a:lstStyle/>
           <a:p>
-            <a:pPr algn="ctr" indent="0" marL="0">
-              <a:buNone/>
-            </a:pPr>
-            <a:r>
-              <a:rPr lang="en-US" sz="1530" b="1" dirty="0">
-                <a:solidFill>
-                  <a:srgbClr val="28143F"/>
-                </a:solidFill>
-                <a:latin typeface="Aptos" pitchFamily="34" charset="0"/>
-                <a:ea typeface="Aptos" pitchFamily="34" charset="-122"/>
-                <a:cs typeface="Aptos" pitchFamily="34" charset="-120"/>
-              </a:rPr>
-              <a:t>Says where the prompt configuration is stored, not where the model computes</a:t>
-            </a:r>
-            <a:endParaRPr lang="en-US" sz="1530" dirty="0"/>
-          </a:p>
-        </p:txBody>
-      </p:sp>
-      <p:sp>
-        <p:nvSpPr>
-          <p:cNvPr id="30" name="Shape 28"/>
-          <p:cNvSpPr/>
-          <p:nvPr/>
-        </p:nvSpPr>
-        <p:spPr>
-          <a:xfrm>
-            <a:off x="7699248" y="4480560"/>
-            <a:ext cx="3401568" cy="786384"/>
-          </a:xfrm>
-          <a:prstGeom prst="roundRect">
-            <a:avLst>
-              <a:gd name="adj" fmla="val 9302"/>
-            </a:avLst>
-          </a:prstGeom>
-          <a:solidFill>
-            <a:srgbClr val="28143F"/>
-          </a:solidFill>
-          <a:ln/>
-        </p:spPr>
-      </p:sp>
-      <p:sp>
-        <p:nvSpPr>
-          <p:cNvPr id="31" name="Text 29"/>
-          <p:cNvSpPr/>
-          <p:nvPr/>
-        </p:nvSpPr>
-        <p:spPr>
-          <a:xfrm>
-            <a:off x="7955280" y="4754880"/>
-            <a:ext cx="2889504" cy="164592"/>
-          </a:xfrm>
-          <a:prstGeom prst="rect">
-            <a:avLst/>
-          </a:prstGeom>
-          <a:noFill/>
-          <a:ln/>
-        </p:spPr>
-        <p:txBody>
-          <a:bodyPr wrap="square" lIns="0" tIns="0" rIns="0" bIns="0" rtlCol="0" anchor="ctr">
-            <a:normAutofit/>
-          </a:bodyPr>
-          <a:lstStyle/>
-          <a:p>
-            <a:pPr algn="ctr" indent="0" marL="0">
-              <a:buNone/>
-            </a:pPr>
-            <a:r>
-              <a:rPr lang="en-US" sz="1450" b="1" dirty="0">
-                <a:solidFill>
-                  <a:srgbClr val="FFFFFF"/>
-                </a:solidFill>
-                <a:latin typeface="Aptos" pitchFamily="34" charset="0"/>
-                <a:ea typeface="Aptos" pitchFamily="34" charset="-122"/>
-                <a:cs typeface="Aptos" pitchFamily="34" charset="-120"/>
-              </a:rPr>
-              <a:t>STORAGE  ≠  INFERENCE</a:t>
-            </a:r>
-            <a:endParaRPr lang="en-US" sz="1450" dirty="0"/>
-          </a:p>
-        </p:txBody>
-      </p:sp>
-      <p:sp>
-        <p:nvSpPr>
-          <p:cNvPr id="32" name="Text 30"/>
-          <p:cNvSpPr/>
-          <p:nvPr/>
-        </p:nvSpPr>
-        <p:spPr>
-          <a:xfrm>
-            <a:off x="658368" y="6318504"/>
-            <a:ext cx="10881360" cy="182880"/>
-          </a:xfrm>
-          <a:prstGeom prst="rect">
-            <a:avLst/>
-          </a:prstGeom>
-          <a:noFill/>
-          <a:ln/>
-        </p:spPr>
-        <p:txBody>
-          <a:bodyPr wrap="square" lIns="0" tIns="0" rIns="0" bIns="0" rtlCol="0" anchor="ctr">
-            <a:normAutofit/>
-          </a:bodyPr>
-          <a:lstStyle/>
-          <a:p>
             <a:pPr indent="0" marL="0">
               <a:buNone/>
             </a:pPr>
@@ -3864,7 +2922,7 @@
                 <a:ea typeface="Aptos" pitchFamily="34" charset="-122"/>
                 <a:cs typeface="Aptos" pitchFamily="34" charset="-120"/>
               </a:rPr>
-              <a:t>REFERENCE  learn.microsoft.com/azure/foundry/agents/concepts/runtime-components  ·  +2 more in notes</a:t>
+              <a:t>REFERENCE  learn.microsoft.com/azure/foundry/how-to/develop/get-started-projects-visual-studio-code  ·  +2 more in notes</a:t>
             </a:r>
             <a:endParaRPr lang="en-US" sz="940" dirty="0"/>
           </a:p>
@@ -3872,7 +2930,7 @@
       </p:sp>
       <p:sp>
         <p:nvSpPr>
-          <p:cNvPr id="33" name="Shape 31"/>
+          <p:cNvPr id="32" name="Shape 30"/>
           <p:cNvSpPr/>
           <p:nvPr/>
         </p:nvSpPr>
@@ -5651,7 +4709,7 @@
                 <a:ea typeface="Aptos" pitchFamily="34" charset="-122"/>
                 <a:cs typeface="Aptos" pitchFamily="34" charset="-120"/>
               </a:rPr>
-              <a:t>REFERENCE  learn.microsoft.com/azure/foundry/agents/how-to/agent-inspector  ·  +2 more in notes</a:t>
+              <a:t>REFERENCE  learn.microsoft.com/azure/foundry/agents/how-to/agent-inspector  ·  +3 more in notes</a:t>
             </a:r>
             <a:endParaRPr lang="en-US" sz="940" dirty="0"/>
           </a:p>
@@ -5807,7 +4865,7 @@
                 <a:ea typeface="Aptos Display" pitchFamily="34" charset="-122"/>
                 <a:cs typeface="Aptos Display" pitchFamily="34" charset="-120"/>
               </a:rPr>
-              <a:t>Choose the surface — then verify the target</a:t>
+              <a:t>Foundry Toolkit: Foundry Features in VS Code</a:t>
             </a:r>
             <a:endParaRPr lang="en-US" sz="3100" dirty="0"/>
           </a:p>
@@ -5982,7 +5040,7 @@
                 <a:ea typeface="Aptos" pitchFamily="34" charset="-122"/>
                 <a:cs typeface="Aptos" pitchFamily="34" charset="-120"/>
               </a:rPr>
-              <a:t>06</a:t>
+              <a:t>07</a:t>
             </a:r>
             <a:endParaRPr lang="en-US" sz="850" dirty="0"/>
           </a:p>
@@ -6340,7 +5398,7 @@
                 <a:ea typeface="Aptos" pitchFamily="34" charset="-122"/>
                 <a:cs typeface="Aptos" pitchFamily="34" charset="-120"/>
               </a:rPr>
-              <a:t>Discover models in Model Catalog and compare prompts and parameters in Model Playground; do not deploy one here.</a:t>
+              <a:t>DISCOVER — Compare models in Model Catalog and find MCP servers or toolboxes in Tool Catalog.</a:t>
             </a:r>
             <a:endParaRPr lang="en-US" sz="1530" dirty="0"/>
           </a:p>
@@ -6467,7 +5525,7 @@
                 <a:ea typeface="Aptos" pitchFamily="34" charset="-122"/>
                 <a:cs typeface="Aptos" pitchFamily="34" charset="-120"/>
               </a:rPr>
-              <a:t>Configure instructions and attached tools in Agent Builder; save before depending on a Foundry version.</a:t>
+              <a:t>BUILD — Configure prompt agents, inspect local runtimes, and deploy through the intended Foundry path.</a:t>
             </a:r>
             <a:endParaRPr lang="en-US" sz="1530" dirty="0"/>
           </a:p>
@@ -6594,7 +5652,7 @@
                 <a:ea typeface="Aptos" pitchFamily="34" charset="-122"/>
                 <a:cs typeface="Aptos" pitchFamily="34" charset="-120"/>
               </a:rPr>
-              <a:t>Inspect a prepared local HTTP/SSE runtime with Agent Inspector; it is not the deployed-agent endpoint.</a:t>
+              <a:t>MONITOR — Use tracing and evaluation as observed evidence, not proof of runtime quality.</a:t>
             </a:r>
             <a:endParaRPr lang="en-US" sz="1530" dirty="0"/>
           </a:p>
@@ -6721,7 +5779,7 @@
                 <a:ea typeface="Aptos" pitchFamily="34" charset="-122"/>
                 <a:cs typeface="Aptos" pitchFamily="34" charset="-120"/>
               </a:rPr>
-              <a:t>Find existing evaluations, conversations, logs, and traces under project resources; cloud traces remain Foundry/Application Insights evidence.</a:t>
+              <a:t>MY RESOURCES — Reopen project evaluations, conversations, logs, traces, models, and agents.</a:t>
             </a:r>
             <a:endParaRPr lang="en-US" sz="1420" dirty="0"/>
           </a:p>
@@ -6848,7 +5906,7 @@
                 <a:ea typeface="Aptos" pitchFamily="34" charset="-122"/>
                 <a:cs typeface="Aptos" pitchFamily="34" charset="-120"/>
               </a:rPr>
-              <a:t>Treat Copilot coding skills as development guidance and agent tools as runtime capabilities — never interchange them.</a:t>
+              <a:t>VERIFY THE TARGET — Check storage, endpoint, version, tools, authorization, and telemetry destination.</a:t>
             </a:r>
             <a:endParaRPr lang="en-US" sz="1530" dirty="0"/>
           </a:p>
@@ -6889,7 +5947,7 @@
                 <a:ea typeface="Aptos" pitchFamily="34" charset="-122"/>
                 <a:cs typeface="Aptos" pitchFamily="34" charset="-120"/>
               </a:rPr>
-              <a:t>REFERENCE  learn.microsoft.com/azure/foundry/how-to/develop/get-started-projects-visual-studio-code  ·  +3 more in notes</a:t>
+              <a:t>REFERENCE  learn.microsoft.com/azure/foundry/how-to/develop/get-started-projects-visual-studio-code  ·  +4 more in notes</a:t>
             </a:r>
             <a:endParaRPr lang="en-US" sz="940" dirty="0"/>
           </a:p>
@@ -6898,6 +5956,1896 @@
       <p:sp>
         <p:nvSpPr>
           <p:cNvPr id="41" name="Shape 39"/>
+          <p:cNvSpPr/>
+          <p:nvPr/>
+        </p:nvSpPr>
+        <p:spPr>
+          <a:xfrm>
+            <a:off x="0" y="6793992"/>
+            <a:ext cx="12191695" cy="64008"/>
+          </a:xfrm>
+          <a:prstGeom prst="rect">
+            <a:avLst/>
+          </a:prstGeom>
+          <a:solidFill>
+            <a:srgbClr val="B88AF7"/>
+          </a:solidFill>
+          <a:ln/>
+        </p:spPr>
+      </p:sp>
+    </p:spTree>
+  </p:cSld>
+  <p:clrMapOvr>
+    <a:masterClrMapping/>
+  </p:clrMapOvr>
+</p:sld>
+</file>
+
+<file path=ppt/slides/slide7.xml><?xml version="1.0" encoding="utf-8"?>
+<p:sld xmlns:a="http://schemas.openxmlformats.org/drawingml/2006/main" xmlns:r="http://schemas.openxmlformats.org/officeDocument/2006/relationships" xmlns:p="http://schemas.openxmlformats.org/presentationml/2006/main">
+  <p:cSld name="Slide 2">
+    <p:bg>
+      <p:bgPr>
+        <a:solidFill>
+          <a:srgbClr val="FCF8FF"/>
+        </a:solidFill>
+      </p:bgPr>
+    </p:bg>
+    <p:spTree>
+      <p:nvGrpSpPr>
+        <p:cNvPr id="1" name=""/>
+        <p:cNvGrpSpPr/>
+        <p:nvPr/>
+      </p:nvGrpSpPr>
+      <p:grpSpPr>
+        <a:xfrm>
+          <a:off x="0" y="0"/>
+          <a:ext cx="0" cy="0"/>
+          <a:chOff x="0" y="0"/>
+          <a:chExt cx="0" cy="0"/>
+        </a:xfrm>
+      </p:grpSpPr>
+      <p:sp>
+        <p:nvSpPr>
+          <p:cNvPr id="2" name="Shape 0"/>
+          <p:cNvSpPr/>
+          <p:nvPr/>
+        </p:nvSpPr>
+        <p:spPr>
+          <a:xfrm>
+            <a:off x="621792" y="438912"/>
+            <a:ext cx="2176272" cy="310896"/>
+          </a:xfrm>
+          <a:prstGeom prst="roundRect">
+            <a:avLst>
+              <a:gd name="adj" fmla="val 23529"/>
+            </a:avLst>
+          </a:prstGeom>
+          <a:solidFill>
+            <a:srgbClr val="28143F"/>
+          </a:solidFill>
+          <a:ln/>
+        </p:spPr>
+      </p:sp>
+      <p:sp>
+        <p:nvSpPr>
+          <p:cNvPr id="3" name="Text 1"/>
+          <p:cNvSpPr/>
+          <p:nvPr/>
+        </p:nvSpPr>
+        <p:spPr>
+          <a:xfrm>
+            <a:off x="768096" y="530352"/>
+            <a:ext cx="1874520" cy="109728"/>
+          </a:xfrm>
+          <a:prstGeom prst="rect">
+            <a:avLst/>
+          </a:prstGeom>
+          <a:noFill/>
+          <a:ln/>
+        </p:spPr>
+        <p:txBody>
+          <a:bodyPr wrap="square" lIns="0" tIns="0" rIns="0" bIns="0" rtlCol="0" anchor="ctr">
+            <a:normAutofit/>
+          </a:bodyPr>
+          <a:lstStyle/>
+          <a:p>
+            <a:pPr indent="0" marL="0">
+              <a:buNone/>
+            </a:pPr>
+            <a:r>
+              <a:rPr lang="en-US" sz="820" b="1" spc="120" kern="0" dirty="0">
+                <a:solidFill>
+                  <a:srgbClr val="FFFFFF"/>
+                </a:solidFill>
+                <a:latin typeface="Aptos" pitchFamily="34" charset="0"/>
+                <a:ea typeface="Aptos" pitchFamily="34" charset="-122"/>
+                <a:cs typeface="Aptos" pitchFamily="34" charset="-120"/>
+              </a:rPr>
+              <a:t>DAY 5  /  MODULE 2  /  DEVELOPER SURFACES</a:t>
+            </a:r>
+            <a:endParaRPr lang="en-US" sz="820" dirty="0"/>
+          </a:p>
+        </p:txBody>
+      </p:sp>
+      <p:sp>
+        <p:nvSpPr>
+          <p:cNvPr id="4" name="Text 2"/>
+          <p:cNvSpPr/>
+          <p:nvPr/>
+        </p:nvSpPr>
+        <p:spPr>
+          <a:xfrm>
+            <a:off x="640080" y="841248"/>
+            <a:ext cx="10012680" cy="475488"/>
+          </a:xfrm>
+          <a:prstGeom prst="rect">
+            <a:avLst/>
+          </a:prstGeom>
+          <a:noFill/>
+          <a:ln/>
+        </p:spPr>
+        <p:txBody>
+          <a:bodyPr wrap="square" lIns="0" tIns="0" rIns="0" bIns="0" rtlCol="0" anchor="ctr">
+            <a:normAutofit/>
+          </a:bodyPr>
+          <a:lstStyle/>
+          <a:p>
+            <a:pPr indent="0" marL="0">
+              <a:buNone/>
+            </a:pPr>
+            <a:r>
+              <a:rPr lang="en-US" sz="3100" b="1" dirty="0">
+                <a:solidFill>
+                  <a:srgbClr val="28143F"/>
+                </a:solidFill>
+                <a:latin typeface="Aptos Display" pitchFamily="34" charset="0"/>
+                <a:ea typeface="Aptos Display" pitchFamily="34" charset="-122"/>
+                <a:cs typeface="Aptos Display" pitchFamily="34" charset="-120"/>
+              </a:rPr>
+              <a:t>How the Toolkit workspace is organized</a:t>
+            </a:r>
+            <a:endParaRPr lang="en-US" sz="3100" dirty="0"/>
+          </a:p>
+        </p:txBody>
+      </p:sp>
+      <p:sp>
+        <p:nvSpPr>
+          <p:cNvPr id="5" name="Shape 3"/>
+          <p:cNvSpPr/>
+          <p:nvPr/>
+        </p:nvSpPr>
+        <p:spPr>
+          <a:xfrm>
+            <a:off x="10804550" y="436717"/>
+            <a:ext cx="592531" cy="500360"/>
+          </a:xfrm>
+          <a:prstGeom prst="roundRect">
+            <a:avLst>
+              <a:gd name="adj" fmla="val 14620"/>
+            </a:avLst>
+          </a:prstGeom>
+          <a:solidFill>
+            <a:srgbClr val="FFFFFF"/>
+          </a:solidFill>
+          <a:ln w="10160">
+            <a:solidFill>
+              <a:srgbClr val="28143F"/>
+            </a:solidFill>
+            <a:prstDash val="solid"/>
+          </a:ln>
+        </p:spPr>
+      </p:sp>
+      <p:sp>
+        <p:nvSpPr>
+          <p:cNvPr id="6" name="Shape 4"/>
+          <p:cNvSpPr/>
+          <p:nvPr/>
+        </p:nvSpPr>
+        <p:spPr>
+          <a:xfrm>
+            <a:off x="10804550" y="436717"/>
+            <a:ext cx="592531" cy="105339"/>
+          </a:xfrm>
+          <a:prstGeom prst="rect">
+            <a:avLst/>
+          </a:prstGeom>
+          <a:solidFill>
+            <a:srgbClr val="B88AF7"/>
+          </a:solidFill>
+          <a:ln/>
+        </p:spPr>
+      </p:sp>
+      <p:sp>
+        <p:nvSpPr>
+          <p:cNvPr id="7" name="Shape 5"/>
+          <p:cNvSpPr/>
+          <p:nvPr/>
+        </p:nvSpPr>
+        <p:spPr>
+          <a:xfrm>
+            <a:off x="10903306" y="640812"/>
+            <a:ext cx="316017" cy="0"/>
+          </a:xfrm>
+          <a:prstGeom prst="line">
+            <a:avLst/>
+          </a:prstGeom>
+          <a:noFill/>
+          <a:ln w="25400">
+            <a:solidFill>
+              <a:srgbClr val="28143F"/>
+            </a:solidFill>
+            <a:prstDash val="solid"/>
+          </a:ln>
+        </p:spPr>
+      </p:sp>
+      <p:sp>
+        <p:nvSpPr>
+          <p:cNvPr id="8" name="Shape 6"/>
+          <p:cNvSpPr/>
+          <p:nvPr/>
+        </p:nvSpPr>
+        <p:spPr>
+          <a:xfrm>
+            <a:off x="10969142" y="746150"/>
+            <a:ext cx="296266" cy="0"/>
+          </a:xfrm>
+          <a:prstGeom prst="line">
+            <a:avLst/>
+          </a:prstGeom>
+          <a:noFill/>
+          <a:ln w="25400">
+            <a:solidFill>
+              <a:srgbClr val="B88AF7"/>
+            </a:solidFill>
+            <a:prstDash val="solid"/>
+          </a:ln>
+        </p:spPr>
+      </p:sp>
+      <p:sp>
+        <p:nvSpPr>
+          <p:cNvPr id="9" name="Shape 7"/>
+          <p:cNvSpPr/>
+          <p:nvPr/>
+        </p:nvSpPr>
+        <p:spPr>
+          <a:xfrm>
+            <a:off x="10890138" y="844906"/>
+            <a:ext cx="204094" cy="0"/>
+          </a:xfrm>
+          <a:prstGeom prst="line">
+            <a:avLst/>
+          </a:prstGeom>
+          <a:noFill/>
+          <a:ln w="25400">
+            <a:solidFill>
+              <a:srgbClr val="28143F"/>
+            </a:solidFill>
+            <a:prstDash val="solid"/>
+          </a:ln>
+        </p:spPr>
+      </p:sp>
+      <p:sp>
+        <p:nvSpPr>
+          <p:cNvPr id="10" name="Shape 8"/>
+          <p:cNvSpPr/>
+          <p:nvPr/>
+        </p:nvSpPr>
+        <p:spPr>
+          <a:xfrm>
+            <a:off x="11612880" y="457200"/>
+            <a:ext cx="329184" cy="329184"/>
+          </a:xfrm>
+          <a:prstGeom prst="ellipse">
+            <a:avLst/>
+          </a:prstGeom>
+          <a:solidFill>
+            <a:srgbClr val="B88AF7"/>
+          </a:solidFill>
+          <a:ln/>
+        </p:spPr>
+      </p:sp>
+      <p:sp>
+        <p:nvSpPr>
+          <p:cNvPr id="11" name="Text 9"/>
+          <p:cNvSpPr/>
+          <p:nvPr/>
+        </p:nvSpPr>
+        <p:spPr>
+          <a:xfrm>
+            <a:off x="11612880" y="553212"/>
+            <a:ext cx="329184" cy="100584"/>
+          </a:xfrm>
+          <a:prstGeom prst="rect">
+            <a:avLst/>
+          </a:prstGeom>
+          <a:noFill/>
+          <a:ln/>
+        </p:spPr>
+        <p:txBody>
+          <a:bodyPr wrap="square" lIns="0" tIns="0" rIns="0" bIns="0" rtlCol="0" anchor="ctr"/>
+          <a:lstStyle/>
+          <a:p>
+            <a:pPr algn="ctr" indent="0" marL="0">
+              <a:buNone/>
+            </a:pPr>
+            <a:r>
+              <a:rPr lang="en-US" sz="850" b="1" dirty="0">
+                <a:solidFill>
+                  <a:srgbClr val="28143F"/>
+                </a:solidFill>
+                <a:latin typeface="Aptos" pitchFamily="34" charset="0"/>
+                <a:ea typeface="Aptos" pitchFamily="34" charset="-122"/>
+                <a:cs typeface="Aptos" pitchFamily="34" charset="-120"/>
+              </a:rPr>
+              <a:t>02</a:t>
+            </a:r>
+            <a:endParaRPr lang="en-US" sz="850" dirty="0"/>
+          </a:p>
+        </p:txBody>
+      </p:sp>
+      <p:sp>
+        <p:nvSpPr>
+          <p:cNvPr id="12" name="Shape 10"/>
+          <p:cNvSpPr/>
+          <p:nvPr/>
+        </p:nvSpPr>
+        <p:spPr>
+          <a:xfrm>
+            <a:off x="9829800" y="1005840"/>
+            <a:ext cx="2148840" cy="2148840"/>
+          </a:xfrm>
+          <a:prstGeom prst="ellipse">
+            <a:avLst/>
+          </a:prstGeom>
+          <a:solidFill>
+            <a:srgbClr val="F1E8FD"/>
+          </a:solidFill>
+          <a:ln/>
+        </p:spPr>
+      </p:sp>
+      <p:sp>
+        <p:nvSpPr>
+          <p:cNvPr id="13" name="Shape 11"/>
+          <p:cNvSpPr/>
+          <p:nvPr/>
+        </p:nvSpPr>
+        <p:spPr>
+          <a:xfrm>
+            <a:off x="640080" y="1417320"/>
+            <a:ext cx="3453384" cy="3730752"/>
+          </a:xfrm>
+          <a:prstGeom prst="roundRect">
+            <a:avLst>
+              <a:gd name="adj" fmla="val 2118"/>
+            </a:avLst>
+          </a:prstGeom>
+          <a:solidFill>
+            <a:srgbClr val="FFFFFF"/>
+          </a:solidFill>
+          <a:ln w="10160">
+            <a:solidFill>
+              <a:srgbClr val="F1E8FD"/>
+            </a:solidFill>
+            <a:prstDash val="solid"/>
+          </a:ln>
+        </p:spPr>
+      </p:sp>
+      <p:sp>
+        <p:nvSpPr>
+          <p:cNvPr id="14" name="Shape 12"/>
+          <p:cNvSpPr/>
+          <p:nvPr/>
+        </p:nvSpPr>
+        <p:spPr>
+          <a:xfrm>
+            <a:off x="914400" y="1719072"/>
+            <a:ext cx="475488" cy="475488"/>
+          </a:xfrm>
+          <a:prstGeom prst="ellipse">
+            <a:avLst/>
+          </a:prstGeom>
+          <a:solidFill>
+            <a:srgbClr val="B88AF7"/>
+          </a:solidFill>
+          <a:ln/>
+        </p:spPr>
+      </p:sp>
+      <p:sp>
+        <p:nvSpPr>
+          <p:cNvPr id="15" name="Text 13"/>
+          <p:cNvSpPr/>
+          <p:nvPr/>
+        </p:nvSpPr>
+        <p:spPr>
+          <a:xfrm>
+            <a:off x="914400" y="1865376"/>
+            <a:ext cx="475488" cy="118872"/>
+          </a:xfrm>
+          <a:prstGeom prst="rect">
+            <a:avLst/>
+          </a:prstGeom>
+          <a:noFill/>
+          <a:ln/>
+        </p:spPr>
+        <p:txBody>
+          <a:bodyPr wrap="square" lIns="0" tIns="0" rIns="0" bIns="0" rtlCol="0" anchor="ctr"/>
+          <a:lstStyle/>
+          <a:p>
+            <a:pPr algn="ctr" indent="0" marL="0">
+              <a:buNone/>
+            </a:pPr>
+            <a:r>
+              <a:rPr lang="en-US" sz="1000" b="1" dirty="0">
+                <a:solidFill>
+                  <a:srgbClr val="28143F"/>
+                </a:solidFill>
+                <a:latin typeface="Aptos" pitchFamily="34" charset="0"/>
+                <a:ea typeface="Aptos" pitchFamily="34" charset="-122"/>
+                <a:cs typeface="Aptos" pitchFamily="34" charset="-120"/>
+              </a:rPr>
+              <a:t>1</a:t>
+            </a:r>
+            <a:endParaRPr lang="en-US" sz="1000" dirty="0"/>
+          </a:p>
+        </p:txBody>
+      </p:sp>
+      <p:sp>
+        <p:nvSpPr>
+          <p:cNvPr id="16" name="Text 14"/>
+          <p:cNvSpPr/>
+          <p:nvPr/>
+        </p:nvSpPr>
+        <p:spPr>
+          <a:xfrm>
+            <a:off x="1572768" y="1728216"/>
+            <a:ext cx="2246376" cy="438912"/>
+          </a:xfrm>
+          <a:prstGeom prst="rect">
+            <a:avLst/>
+          </a:prstGeom>
+          <a:noFill/>
+          <a:ln/>
+        </p:spPr>
+        <p:txBody>
+          <a:bodyPr wrap="square" lIns="0" tIns="0" rIns="0" bIns="0" rtlCol="0" anchor="ctr">
+            <a:normAutofit/>
+          </a:bodyPr>
+          <a:lstStyle/>
+          <a:p>
+            <a:pPr indent="0" marL="0">
+              <a:buNone/>
+            </a:pPr>
+            <a:r>
+              <a:rPr lang="en-US" sz="2000" b="1" dirty="0">
+                <a:solidFill>
+                  <a:srgbClr val="28143F"/>
+                </a:solidFill>
+                <a:latin typeface="Aptos Display" pitchFamily="34" charset="0"/>
+                <a:ea typeface="Aptos Display" pitchFamily="34" charset="-122"/>
+                <a:cs typeface="Aptos Display" pitchFamily="34" charset="-120"/>
+              </a:rPr>
+              <a:t>My Resources</a:t>
+            </a:r>
+            <a:endParaRPr lang="en-US" sz="2000" dirty="0"/>
+          </a:p>
+        </p:txBody>
+      </p:sp>
+      <p:sp>
+        <p:nvSpPr>
+          <p:cNvPr id="17" name="Text 15"/>
+          <p:cNvSpPr/>
+          <p:nvPr/>
+        </p:nvSpPr>
+        <p:spPr>
+          <a:xfrm>
+            <a:off x="932688" y="2523744"/>
+            <a:ext cx="2868168" cy="1609344"/>
+          </a:xfrm>
+          <a:prstGeom prst="rect">
+            <a:avLst/>
+          </a:prstGeom>
+          <a:noFill/>
+          <a:ln/>
+        </p:spPr>
+        <p:txBody>
+          <a:bodyPr wrap="square" lIns="0" tIns="0" rIns="0" bIns="0" rtlCol="0" anchor="ctr">
+            <a:normAutofit/>
+          </a:bodyPr>
+          <a:lstStyle/>
+          <a:p>
+            <a:pPr marL="228600" indent="-171450">
+              <a:buChar char="•"/>
+            </a:pPr>
+            <a:r>
+              <a:rPr lang="en-US" sz="1520" dirty="0">
+                <a:solidFill>
+                  <a:srgbClr val="251B33"/>
+                </a:solidFill>
+                <a:latin typeface="Aptos" pitchFamily="34" charset="0"/>
+                <a:ea typeface="Aptos" pitchFamily="34" charset="-122"/>
+                <a:cs typeface="Aptos" pitchFamily="34" charset="-120"/>
+              </a:rPr>
+              <a:t>Local Resources</a:t>
+            </a:r>
+            <a:endParaRPr lang="en-US" sz="1520" dirty="0"/>
+          </a:p>
+          <a:p>
+            <a:pPr marL="228600" indent="-171450">
+              <a:buChar char="•"/>
+            </a:pPr>
+            <a:r>
+              <a:rPr lang="en-US" sz="1520" dirty="0">
+                <a:solidFill>
+                  <a:srgbClr val="251B33"/>
+                </a:solidFill>
+                <a:latin typeface="Aptos" pitchFamily="34" charset="0"/>
+                <a:ea typeface="Aptos" pitchFamily="34" charset="-122"/>
+                <a:cs typeface="Aptos" pitchFamily="34" charset="-120"/>
+              </a:rPr>
+              <a:t>Your Foundry Project</a:t>
+            </a:r>
+            <a:endParaRPr lang="en-US" sz="1520" dirty="0"/>
+          </a:p>
+          <a:p>
+            <a:pPr marL="228600" indent="-171450">
+              <a:buChar char="•"/>
+            </a:pPr>
+            <a:r>
+              <a:rPr lang="en-US" sz="1520" dirty="0">
+                <a:solidFill>
+                  <a:srgbClr val="251B33"/>
+                </a:solidFill>
+                <a:latin typeface="Aptos" pitchFamily="34" charset="0"/>
+                <a:ea typeface="Aptos" pitchFamily="34" charset="-122"/>
+                <a:cs typeface="Aptos" pitchFamily="34" charset="-120"/>
+              </a:rPr>
+              <a:t>Connected Resources</a:t>
+            </a:r>
+            <a:endParaRPr lang="en-US" sz="1520" dirty="0"/>
+          </a:p>
+        </p:txBody>
+      </p:sp>
+      <p:sp>
+        <p:nvSpPr>
+          <p:cNvPr id="18" name="Shape 16"/>
+          <p:cNvSpPr/>
+          <p:nvPr/>
+        </p:nvSpPr>
+        <p:spPr>
+          <a:xfrm>
+            <a:off x="4367784" y="1417320"/>
+            <a:ext cx="3453384" cy="3730752"/>
+          </a:xfrm>
+          <a:prstGeom prst="roundRect">
+            <a:avLst>
+              <a:gd name="adj" fmla="val 2118"/>
+            </a:avLst>
+          </a:prstGeom>
+          <a:solidFill>
+            <a:srgbClr val="FFFFFF"/>
+          </a:solidFill>
+          <a:ln w="10160">
+            <a:solidFill>
+              <a:srgbClr val="F1E8FD"/>
+            </a:solidFill>
+            <a:prstDash val="solid"/>
+          </a:ln>
+        </p:spPr>
+      </p:sp>
+      <p:sp>
+        <p:nvSpPr>
+          <p:cNvPr id="19" name="Shape 17"/>
+          <p:cNvSpPr/>
+          <p:nvPr/>
+        </p:nvSpPr>
+        <p:spPr>
+          <a:xfrm>
+            <a:off x="4642104" y="1719072"/>
+            <a:ext cx="475488" cy="475488"/>
+          </a:xfrm>
+          <a:prstGeom prst="ellipse">
+            <a:avLst/>
+          </a:prstGeom>
+          <a:solidFill>
+            <a:srgbClr val="FFB454"/>
+          </a:solidFill>
+          <a:ln/>
+        </p:spPr>
+      </p:sp>
+      <p:sp>
+        <p:nvSpPr>
+          <p:cNvPr id="20" name="Text 18"/>
+          <p:cNvSpPr/>
+          <p:nvPr/>
+        </p:nvSpPr>
+        <p:spPr>
+          <a:xfrm>
+            <a:off x="4642104" y="1865376"/>
+            <a:ext cx="475488" cy="118872"/>
+          </a:xfrm>
+          <a:prstGeom prst="rect">
+            <a:avLst/>
+          </a:prstGeom>
+          <a:noFill/>
+          <a:ln/>
+        </p:spPr>
+        <p:txBody>
+          <a:bodyPr wrap="square" lIns="0" tIns="0" rIns="0" bIns="0" rtlCol="0" anchor="ctr"/>
+          <a:lstStyle/>
+          <a:p>
+            <a:pPr algn="ctr" indent="0" marL="0">
+              <a:buNone/>
+            </a:pPr>
+            <a:r>
+              <a:rPr lang="en-US" sz="1000" b="1" dirty="0">
+                <a:solidFill>
+                  <a:srgbClr val="28143F"/>
+                </a:solidFill>
+                <a:latin typeface="Aptos" pitchFamily="34" charset="0"/>
+                <a:ea typeface="Aptos" pitchFamily="34" charset="-122"/>
+                <a:cs typeface="Aptos" pitchFamily="34" charset="-120"/>
+              </a:rPr>
+              <a:t>2</a:t>
+            </a:r>
+            <a:endParaRPr lang="en-US" sz="1000" dirty="0"/>
+          </a:p>
+        </p:txBody>
+      </p:sp>
+      <p:sp>
+        <p:nvSpPr>
+          <p:cNvPr id="21" name="Text 19"/>
+          <p:cNvSpPr/>
+          <p:nvPr/>
+        </p:nvSpPr>
+        <p:spPr>
+          <a:xfrm>
+            <a:off x="5300472" y="1728216"/>
+            <a:ext cx="2246376" cy="438912"/>
+          </a:xfrm>
+          <a:prstGeom prst="rect">
+            <a:avLst/>
+          </a:prstGeom>
+          <a:noFill/>
+          <a:ln/>
+        </p:spPr>
+        <p:txBody>
+          <a:bodyPr wrap="square" lIns="0" tIns="0" rIns="0" bIns="0" rtlCol="0" anchor="ctr">
+            <a:normAutofit/>
+          </a:bodyPr>
+          <a:lstStyle/>
+          <a:p>
+            <a:pPr indent="0" marL="0">
+              <a:buNone/>
+            </a:pPr>
+            <a:r>
+              <a:rPr lang="en-US" sz="2000" b="1" dirty="0">
+                <a:solidFill>
+                  <a:srgbClr val="28143F"/>
+                </a:solidFill>
+                <a:latin typeface="Aptos Display" pitchFamily="34" charset="0"/>
+                <a:ea typeface="Aptos Display" pitchFamily="34" charset="-122"/>
+                <a:cs typeface="Aptos Display" pitchFamily="34" charset="-120"/>
+              </a:rPr>
+              <a:t>Developer Tools</a:t>
+            </a:r>
+            <a:endParaRPr lang="en-US" sz="2000" dirty="0"/>
+          </a:p>
+        </p:txBody>
+      </p:sp>
+      <p:sp>
+        <p:nvSpPr>
+          <p:cNvPr id="22" name="Text 20"/>
+          <p:cNvSpPr/>
+          <p:nvPr/>
+        </p:nvSpPr>
+        <p:spPr>
+          <a:xfrm>
+            <a:off x="4660392" y="2523744"/>
+            <a:ext cx="2868168" cy="1609344"/>
+          </a:xfrm>
+          <a:prstGeom prst="rect">
+            <a:avLst/>
+          </a:prstGeom>
+          <a:noFill/>
+          <a:ln/>
+        </p:spPr>
+        <p:txBody>
+          <a:bodyPr wrap="square" lIns="0" tIns="0" rIns="0" bIns="0" rtlCol="0" anchor="ctr">
+            <a:normAutofit/>
+          </a:bodyPr>
+          <a:lstStyle/>
+          <a:p>
+            <a:pPr marL="228600" indent="-171450">
+              <a:buChar char="•"/>
+            </a:pPr>
+            <a:r>
+              <a:rPr lang="en-US" sz="1520" dirty="0">
+                <a:solidFill>
+                  <a:srgbClr val="251B33"/>
+                </a:solidFill>
+                <a:latin typeface="Aptos" pitchFamily="34" charset="0"/>
+                <a:ea typeface="Aptos" pitchFamily="34" charset="-122"/>
+                <a:cs typeface="Aptos" pitchFamily="34" charset="-120"/>
+              </a:rPr>
+              <a:t>Discover</a:t>
+            </a:r>
+            <a:endParaRPr lang="en-US" sz="1520" dirty="0"/>
+          </a:p>
+          <a:p>
+            <a:pPr marL="228600" indent="-171450">
+              <a:buChar char="•"/>
+            </a:pPr>
+            <a:r>
+              <a:rPr lang="en-US" sz="1520" dirty="0">
+                <a:solidFill>
+                  <a:srgbClr val="251B33"/>
+                </a:solidFill>
+                <a:latin typeface="Aptos" pitchFamily="34" charset="0"/>
+                <a:ea typeface="Aptos" pitchFamily="34" charset="-122"/>
+                <a:cs typeface="Aptos" pitchFamily="34" charset="-120"/>
+              </a:rPr>
+              <a:t>Build</a:t>
+            </a:r>
+            <a:endParaRPr lang="en-US" sz="1520" dirty="0"/>
+          </a:p>
+          <a:p>
+            <a:pPr marL="228600" indent="-171450">
+              <a:buChar char="•"/>
+            </a:pPr>
+            <a:r>
+              <a:rPr lang="en-US" sz="1520" dirty="0">
+                <a:solidFill>
+                  <a:srgbClr val="251B33"/>
+                </a:solidFill>
+                <a:latin typeface="Aptos" pitchFamily="34" charset="0"/>
+                <a:ea typeface="Aptos" pitchFamily="34" charset="-122"/>
+                <a:cs typeface="Aptos" pitchFamily="34" charset="-120"/>
+              </a:rPr>
+              <a:t>Monitor</a:t>
+            </a:r>
+            <a:endParaRPr lang="en-US" sz="1520" dirty="0"/>
+          </a:p>
+        </p:txBody>
+      </p:sp>
+      <p:sp>
+        <p:nvSpPr>
+          <p:cNvPr id="23" name="Shape 21"/>
+          <p:cNvSpPr/>
+          <p:nvPr/>
+        </p:nvSpPr>
+        <p:spPr>
+          <a:xfrm>
+            <a:off x="8095488" y="1417320"/>
+            <a:ext cx="3453384" cy="3730752"/>
+          </a:xfrm>
+          <a:prstGeom prst="roundRect">
+            <a:avLst>
+              <a:gd name="adj" fmla="val 2118"/>
+            </a:avLst>
+          </a:prstGeom>
+          <a:solidFill>
+            <a:srgbClr val="FFFFFF"/>
+          </a:solidFill>
+          <a:ln w="10160">
+            <a:solidFill>
+              <a:srgbClr val="F1E8FD"/>
+            </a:solidFill>
+            <a:prstDash val="solid"/>
+          </a:ln>
+        </p:spPr>
+      </p:sp>
+      <p:sp>
+        <p:nvSpPr>
+          <p:cNvPr id="24" name="Shape 22"/>
+          <p:cNvSpPr/>
+          <p:nvPr/>
+        </p:nvSpPr>
+        <p:spPr>
+          <a:xfrm>
+            <a:off x="8369808" y="1719072"/>
+            <a:ext cx="475488" cy="475488"/>
+          </a:xfrm>
+          <a:prstGeom prst="ellipse">
+            <a:avLst/>
+          </a:prstGeom>
+          <a:solidFill>
+            <a:srgbClr val="B88AF7"/>
+          </a:solidFill>
+          <a:ln/>
+        </p:spPr>
+      </p:sp>
+      <p:sp>
+        <p:nvSpPr>
+          <p:cNvPr id="25" name="Text 23"/>
+          <p:cNvSpPr/>
+          <p:nvPr/>
+        </p:nvSpPr>
+        <p:spPr>
+          <a:xfrm>
+            <a:off x="8369808" y="1865376"/>
+            <a:ext cx="475488" cy="118872"/>
+          </a:xfrm>
+          <a:prstGeom prst="rect">
+            <a:avLst/>
+          </a:prstGeom>
+          <a:noFill/>
+          <a:ln/>
+        </p:spPr>
+        <p:txBody>
+          <a:bodyPr wrap="square" lIns="0" tIns="0" rIns="0" bIns="0" rtlCol="0" anchor="ctr"/>
+          <a:lstStyle/>
+          <a:p>
+            <a:pPr algn="ctr" indent="0" marL="0">
+              <a:buNone/>
+            </a:pPr>
+            <a:r>
+              <a:rPr lang="en-US" sz="1000" b="1" dirty="0">
+                <a:solidFill>
+                  <a:srgbClr val="28143F"/>
+                </a:solidFill>
+                <a:latin typeface="Aptos" pitchFamily="34" charset="0"/>
+                <a:ea typeface="Aptos" pitchFamily="34" charset="-122"/>
+                <a:cs typeface="Aptos" pitchFamily="34" charset="-120"/>
+              </a:rPr>
+              <a:t>3</a:t>
+            </a:r>
+            <a:endParaRPr lang="en-US" sz="1000" dirty="0"/>
+          </a:p>
+        </p:txBody>
+      </p:sp>
+      <p:sp>
+        <p:nvSpPr>
+          <p:cNvPr id="26" name="Text 24"/>
+          <p:cNvSpPr/>
+          <p:nvPr/>
+        </p:nvSpPr>
+        <p:spPr>
+          <a:xfrm>
+            <a:off x="9028176" y="1728216"/>
+            <a:ext cx="2246376" cy="438912"/>
+          </a:xfrm>
+          <a:prstGeom prst="rect">
+            <a:avLst/>
+          </a:prstGeom>
+          <a:noFill/>
+          <a:ln/>
+        </p:spPr>
+        <p:txBody>
+          <a:bodyPr wrap="square" lIns="0" tIns="0" rIns="0" bIns="0" rtlCol="0" anchor="ctr">
+            <a:normAutofit/>
+          </a:bodyPr>
+          <a:lstStyle/>
+          <a:p>
+            <a:pPr indent="0" marL="0">
+              <a:buNone/>
+            </a:pPr>
+            <a:r>
+              <a:rPr lang="en-US" sz="2000" b="1" dirty="0">
+                <a:solidFill>
+                  <a:srgbClr val="28143F"/>
+                </a:solidFill>
+                <a:latin typeface="Aptos Display" pitchFamily="34" charset="0"/>
+                <a:ea typeface="Aptos Display" pitchFamily="34" charset="-122"/>
+                <a:cs typeface="Aptos Display" pitchFamily="34" charset="-120"/>
+              </a:rPr>
+              <a:t>Help and Feedback</a:t>
+            </a:r>
+            <a:endParaRPr lang="en-US" sz="2000" dirty="0"/>
+          </a:p>
+        </p:txBody>
+      </p:sp>
+      <p:sp>
+        <p:nvSpPr>
+          <p:cNvPr id="27" name="Text 25"/>
+          <p:cNvSpPr/>
+          <p:nvPr/>
+        </p:nvSpPr>
+        <p:spPr>
+          <a:xfrm>
+            <a:off x="8388096" y="2523744"/>
+            <a:ext cx="2868168" cy="1609344"/>
+          </a:xfrm>
+          <a:prstGeom prst="rect">
+            <a:avLst/>
+          </a:prstGeom>
+          <a:noFill/>
+          <a:ln/>
+        </p:spPr>
+        <p:txBody>
+          <a:bodyPr wrap="square" lIns="0" tIns="0" rIns="0" bIns="0" rtlCol="0" anchor="ctr">
+            <a:normAutofit/>
+          </a:bodyPr>
+          <a:lstStyle/>
+          <a:p>
+            <a:pPr marL="228600" indent="-171450">
+              <a:buChar char="•"/>
+            </a:pPr>
+            <a:r>
+              <a:rPr lang="en-US" sz="1520" dirty="0">
+                <a:solidFill>
+                  <a:srgbClr val="251B33"/>
+                </a:solidFill>
+                <a:latin typeface="Aptos" pitchFamily="34" charset="0"/>
+                <a:ea typeface="Aptos" pitchFamily="34" charset="-122"/>
+                <a:cs typeface="Aptos" pitchFamily="34" charset="-120"/>
+              </a:rPr>
+              <a:t>Documentation + What’s New</a:t>
+            </a:r>
+            <a:endParaRPr lang="en-US" sz="1520" dirty="0"/>
+          </a:p>
+          <a:p>
+            <a:pPr marL="228600" indent="-171450">
+              <a:buChar char="•"/>
+            </a:pPr>
+            <a:r>
+              <a:rPr lang="en-US" sz="1520" dirty="0">
+                <a:solidFill>
+                  <a:srgbClr val="251B33"/>
+                </a:solidFill>
+                <a:latin typeface="Aptos" pitchFamily="34" charset="0"/>
+                <a:ea typeface="Aptos" pitchFamily="34" charset="-122"/>
+                <a:cs typeface="Aptos" pitchFamily="34" charset="-120"/>
+              </a:rPr>
+              <a:t>Report Issues</a:t>
+            </a:r>
+            <a:endParaRPr lang="en-US" sz="1520" dirty="0"/>
+          </a:p>
+          <a:p>
+            <a:pPr marL="228600" indent="-171450">
+              <a:buChar char="•"/>
+            </a:pPr>
+            <a:r>
+              <a:rPr lang="en-US" sz="1520" dirty="0">
+                <a:solidFill>
+                  <a:srgbClr val="251B33"/>
+                </a:solidFill>
+                <a:latin typeface="Aptos" pitchFamily="34" charset="0"/>
+                <a:ea typeface="Aptos" pitchFamily="34" charset="-122"/>
+                <a:cs typeface="Aptos" pitchFamily="34" charset="-120"/>
+              </a:rPr>
+              <a:t>Join Community</a:t>
+            </a:r>
+            <a:endParaRPr lang="en-US" sz="1520" dirty="0"/>
+          </a:p>
+        </p:txBody>
+      </p:sp>
+      <p:sp>
+        <p:nvSpPr>
+          <p:cNvPr id="28" name="Shape 26"/>
+          <p:cNvSpPr/>
+          <p:nvPr/>
+        </p:nvSpPr>
+        <p:spPr>
+          <a:xfrm>
+            <a:off x="1024128" y="5376672"/>
+            <a:ext cx="10104120" cy="621792"/>
+          </a:xfrm>
+          <a:prstGeom prst="roundRect">
+            <a:avLst>
+              <a:gd name="adj" fmla="val 11765"/>
+            </a:avLst>
+          </a:prstGeom>
+          <a:solidFill>
+            <a:srgbClr val="28143F"/>
+          </a:solidFill>
+          <a:ln/>
+        </p:spPr>
+      </p:sp>
+      <p:sp>
+        <p:nvSpPr>
+          <p:cNvPr id="29" name="Text 27"/>
+          <p:cNvSpPr/>
+          <p:nvPr/>
+        </p:nvSpPr>
+        <p:spPr>
+          <a:xfrm>
+            <a:off x="1280160" y="5586984"/>
+            <a:ext cx="1325880" cy="146304"/>
+          </a:xfrm>
+          <a:prstGeom prst="rect">
+            <a:avLst/>
+          </a:prstGeom>
+          <a:noFill/>
+          <a:ln/>
+        </p:spPr>
+        <p:txBody>
+          <a:bodyPr wrap="square" lIns="0" tIns="0" rIns="0" bIns="0" rtlCol="0" anchor="ctr"/>
+          <a:lstStyle/>
+          <a:p>
+            <a:pPr indent="0" marL="0">
+              <a:buNone/>
+            </a:pPr>
+            <a:r>
+              <a:rPr lang="en-US" sz="1000" b="1" spc="140" kern="0" dirty="0">
+                <a:solidFill>
+                  <a:srgbClr val="FFB454"/>
+                </a:solidFill>
+                <a:latin typeface="Aptos" pitchFamily="34" charset="0"/>
+                <a:ea typeface="Aptos" pitchFamily="34" charset="-122"/>
+                <a:cs typeface="Aptos" pitchFamily="34" charset="-120"/>
+              </a:rPr>
+              <a:t>WORKSPACE</a:t>
+            </a:r>
+            <a:endParaRPr lang="en-US" sz="1000" dirty="0"/>
+          </a:p>
+        </p:txBody>
+      </p:sp>
+      <p:sp>
+        <p:nvSpPr>
+          <p:cNvPr id="30" name="Text 28"/>
+          <p:cNvSpPr/>
+          <p:nvPr/>
+        </p:nvSpPr>
+        <p:spPr>
+          <a:xfrm>
+            <a:off x="2743200" y="5541264"/>
+            <a:ext cx="8028432" cy="237744"/>
+          </a:xfrm>
+          <a:prstGeom prst="rect">
+            <a:avLst/>
+          </a:prstGeom>
+          <a:noFill/>
+          <a:ln/>
+        </p:spPr>
+        <p:txBody>
+          <a:bodyPr wrap="square" lIns="0" tIns="0" rIns="0" bIns="0" rtlCol="0" anchor="ctr">
+            <a:normAutofit/>
+          </a:bodyPr>
+          <a:lstStyle/>
+          <a:p>
+            <a:pPr indent="0" marL="0">
+              <a:buNone/>
+            </a:pPr>
+            <a:r>
+              <a:rPr lang="en-US" sz="1420" b="1" dirty="0">
+                <a:solidFill>
+                  <a:srgbClr val="FFFFFF"/>
+                </a:solidFill>
+                <a:latin typeface="Aptos" pitchFamily="34" charset="0"/>
+                <a:ea typeface="Aptos" pitchFamily="34" charset="-122"/>
+                <a:cs typeface="Aptos" pitchFamily="34" charset="-120"/>
+              </a:rPr>
+              <a:t>My Resources shows what you have; Developer Tools groups actions as Discover, Build, and Monitor.</a:t>
+            </a:r>
+            <a:endParaRPr lang="en-US" sz="1420" dirty="0"/>
+          </a:p>
+        </p:txBody>
+      </p:sp>
+      <p:sp>
+        <p:nvSpPr>
+          <p:cNvPr id="31" name="Text 29"/>
+          <p:cNvSpPr/>
+          <p:nvPr/>
+        </p:nvSpPr>
+        <p:spPr>
+          <a:xfrm>
+            <a:off x="658368" y="6318504"/>
+            <a:ext cx="10881360" cy="182880"/>
+          </a:xfrm>
+          <a:prstGeom prst="rect">
+            <a:avLst/>
+          </a:prstGeom>
+          <a:noFill/>
+          <a:ln/>
+        </p:spPr>
+        <p:txBody>
+          <a:bodyPr wrap="square" lIns="0" tIns="0" rIns="0" bIns="0" rtlCol="0" anchor="ctr">
+            <a:normAutofit/>
+          </a:bodyPr>
+          <a:lstStyle/>
+          <a:p>
+            <a:pPr indent="0" marL="0">
+              <a:buNone/>
+            </a:pPr>
+            <a:r>
+              <a:rPr lang="en-US" sz="940" dirty="0">
+                <a:solidFill>
+                  <a:srgbClr val="6D5A78"/>
+                </a:solidFill>
+                <a:latin typeface="Aptos" pitchFamily="34" charset="0"/>
+                <a:ea typeface="Aptos" pitchFamily="34" charset="-122"/>
+                <a:cs typeface="Aptos" pitchFamily="34" charset="-120"/>
+              </a:rPr>
+              <a:t>REFERENCE  learn.microsoft.com/azure/foundry/how-to/develop/get-started-projects-visual-studio-code  ·  +1 more in notes</a:t>
+            </a:r>
+            <a:endParaRPr lang="en-US" sz="940" dirty="0"/>
+          </a:p>
+        </p:txBody>
+      </p:sp>
+      <p:sp>
+        <p:nvSpPr>
+          <p:cNvPr id="32" name="Shape 30"/>
+          <p:cNvSpPr/>
+          <p:nvPr/>
+        </p:nvSpPr>
+        <p:spPr>
+          <a:xfrm>
+            <a:off x="0" y="6793992"/>
+            <a:ext cx="12191695" cy="64008"/>
+          </a:xfrm>
+          <a:prstGeom prst="rect">
+            <a:avLst/>
+          </a:prstGeom>
+          <a:solidFill>
+            <a:srgbClr val="B88AF7"/>
+          </a:solidFill>
+          <a:ln/>
+        </p:spPr>
+      </p:sp>
+    </p:spTree>
+  </p:cSld>
+  <p:clrMapOvr>
+    <a:masterClrMapping/>
+  </p:clrMapOvr>
+</p:sld>
+</file>
+
+<file path=ppt/slides/slide8.xml><?xml version="1.0" encoding="utf-8"?>
+<p:sld xmlns:a="http://schemas.openxmlformats.org/drawingml/2006/main" xmlns:r="http://schemas.openxmlformats.org/officeDocument/2006/relationships" xmlns:p="http://schemas.openxmlformats.org/presentationml/2006/main">
+  <p:cSld name="Slide 6">
+    <p:bg>
+      <p:bgPr>
+        <a:solidFill>
+          <a:srgbClr val="28143F"/>
+        </a:solidFill>
+      </p:bgPr>
+    </p:bg>
+    <p:spTree>
+      <p:nvGrpSpPr>
+        <p:cNvPr id="1" name=""/>
+        <p:cNvGrpSpPr/>
+        <p:nvPr/>
+      </p:nvGrpSpPr>
+      <p:grpSpPr>
+        <a:xfrm>
+          <a:off x="0" y="0"/>
+          <a:ext cx="0" cy="0"/>
+          <a:chOff x="0" y="0"/>
+          <a:chExt cx="0" cy="0"/>
+        </a:xfrm>
+      </p:grpSpPr>
+      <p:sp>
+        <p:nvSpPr>
+          <p:cNvPr id="2" name="Shape 0"/>
+          <p:cNvSpPr/>
+          <p:nvPr/>
+        </p:nvSpPr>
+        <p:spPr>
+          <a:xfrm>
+            <a:off x="182880" y="4407408"/>
+            <a:ext cx="1572768" cy="1572768"/>
+          </a:xfrm>
+          <a:prstGeom prst="ellipse">
+            <a:avLst/>
+          </a:prstGeom>
+          <a:solidFill>
+            <a:srgbClr val="FFF1D9"/>
+          </a:solidFill>
+          <a:ln/>
+        </p:spPr>
+      </p:sp>
+      <p:sp>
+        <p:nvSpPr>
+          <p:cNvPr id="3" name="Shape 1"/>
+          <p:cNvSpPr/>
+          <p:nvPr/>
+        </p:nvSpPr>
+        <p:spPr>
+          <a:xfrm>
+            <a:off x="457200" y="4681728"/>
+            <a:ext cx="1024128" cy="1024128"/>
+          </a:xfrm>
+          <a:prstGeom prst="ellipse">
+            <a:avLst/>
+          </a:prstGeom>
+          <a:solidFill>
+            <a:srgbClr val="28143F"/>
+          </a:solidFill>
+          <a:ln/>
+        </p:spPr>
+      </p:sp>
+      <p:sp>
+        <p:nvSpPr>
+          <p:cNvPr id="4" name="Text 2"/>
+          <p:cNvSpPr/>
+          <p:nvPr/>
+        </p:nvSpPr>
+        <p:spPr>
+          <a:xfrm>
+            <a:off x="713232" y="530352"/>
+            <a:ext cx="2560320" cy="256032"/>
+          </a:xfrm>
+          <a:prstGeom prst="rect">
+            <a:avLst/>
+          </a:prstGeom>
+          <a:noFill/>
+          <a:ln/>
+        </p:spPr>
+        <p:txBody>
+          <a:bodyPr wrap="square" lIns="0" tIns="0" rIns="0" bIns="0" rtlCol="0" anchor="ctr"/>
+          <a:lstStyle/>
+          <a:p>
+            <a:pPr indent="0" marL="0">
+              <a:buNone/>
+            </a:pPr>
+            <a:r>
+              <a:rPr lang="en-US" sz="1200" b="1" spc="350" kern="0" dirty="0">
+                <a:solidFill>
+                  <a:srgbClr val="B88AF7"/>
+                </a:solidFill>
+                <a:latin typeface="Aptos" pitchFamily="34" charset="0"/>
+                <a:ea typeface="Aptos" pitchFamily="34" charset="-122"/>
+                <a:cs typeface="Aptos" pitchFamily="34" charset="-120"/>
+              </a:rPr>
+              <a:t>LIVE DEMO</a:t>
+            </a:r>
+            <a:endParaRPr lang="en-US" sz="1200" dirty="0"/>
+          </a:p>
+        </p:txBody>
+      </p:sp>
+      <p:sp>
+        <p:nvSpPr>
+          <p:cNvPr id="5" name="Text 3"/>
+          <p:cNvSpPr/>
+          <p:nvPr/>
+        </p:nvSpPr>
+        <p:spPr>
+          <a:xfrm>
+            <a:off x="713232" y="1143000"/>
+            <a:ext cx="6199632" cy="914400"/>
+          </a:xfrm>
+          <a:prstGeom prst="rect">
+            <a:avLst/>
+          </a:prstGeom>
+          <a:noFill/>
+          <a:ln/>
+        </p:spPr>
+        <p:txBody>
+          <a:bodyPr wrap="square" lIns="0" tIns="0" rIns="0" bIns="0" rtlCol="0" anchor="ctr">
+            <a:normAutofit/>
+          </a:bodyPr>
+          <a:lstStyle/>
+          <a:p>
+            <a:pPr indent="0" marL="0">
+              <a:buNone/>
+            </a:pPr>
+            <a:r>
+              <a:rPr lang="en-US" sz="3500" b="1" dirty="0">
+                <a:solidFill>
+                  <a:srgbClr val="FFFFFF"/>
+                </a:solidFill>
+                <a:latin typeface="Aptos Display" pitchFamily="34" charset="0"/>
+                <a:ea typeface="Aptos Display" pitchFamily="34" charset="-122"/>
+                <a:cs typeface="Aptos Display" pitchFamily="34" charset="-120"/>
+              </a:rPr>
+              <a:t>Trace local code in</a:t>
+            </a:r>
+            <a:endParaRPr lang="en-US" sz="3500" dirty="0"/>
+          </a:p>
+          <a:p>
+            <a:pPr indent="0" marL="0">
+              <a:buNone/>
+            </a:pPr>
+            <a:r>
+              <a:rPr lang="en-US" sz="3500" b="1" dirty="0">
+                <a:solidFill>
+                  <a:srgbClr val="FFFFFF"/>
+                </a:solidFill>
+                <a:latin typeface="Aptos Display" pitchFamily="34" charset="0"/>
+                <a:ea typeface="Aptos Display" pitchFamily="34" charset="-122"/>
+                <a:cs typeface="Aptos Display" pitchFamily="34" charset="-120"/>
+              </a:rPr>
+              <a:t>Toolkit Tracing</a:t>
+            </a:r>
+            <a:endParaRPr lang="en-US" sz="3500" dirty="0"/>
+          </a:p>
+        </p:txBody>
+      </p:sp>
+      <p:sp>
+        <p:nvSpPr>
+          <p:cNvPr id="6" name="Text 4"/>
+          <p:cNvSpPr/>
+          <p:nvPr/>
+        </p:nvSpPr>
+        <p:spPr>
+          <a:xfrm>
+            <a:off x="749808" y="2395728"/>
+            <a:ext cx="6473952" cy="2057400"/>
+          </a:xfrm>
+          <a:prstGeom prst="rect">
+            <a:avLst/>
+          </a:prstGeom>
+          <a:noFill/>
+          <a:ln/>
+        </p:spPr>
+        <p:txBody>
+          <a:bodyPr wrap="square" lIns="0" tIns="0" rIns="0" bIns="0" rtlCol="0" anchor="t">
+            <a:normAutofit/>
+          </a:bodyPr>
+          <a:lstStyle/>
+          <a:p>
+            <a:pPr indent="0" marL="0">
+              <a:buNone/>
+            </a:pPr>
+            <a:r>
+              <a:rPr lang="en-US" sz="1540" dirty="0">
+                <a:solidFill>
+                  <a:srgbClr val="E5EBF0"/>
+                </a:solidFill>
+                <a:latin typeface="Aptos" pitchFamily="34" charset="0"/>
+                <a:ea typeface="Aptos" pitchFamily="34" charset="-122"/>
+                <a:cs typeface="Aptos" pitchFamily="34" charset="-120"/>
+              </a:rPr>
+              <a:t>Start the local OTLP collector in the Toolkit Tracing view.</a:t>
+            </a:r>
+            <a:endParaRPr lang="en-US" sz="1540" dirty="0"/>
+          </a:p>
+          <a:p>
+            <a:pPr indent="0" marL="0">
+              <a:buNone/>
+            </a:pPr>
+            <a:r>
+              <a:rPr lang="en-US" sz="1540" dirty="0">
+                <a:solidFill>
+                  <a:srgbClr val="E5EBF0"/>
+                </a:solidFill>
+                <a:latin typeface="Aptos" pitchFamily="34" charset="0"/>
+                <a:ea typeface="Aptos" pitchFamily="34" charset="-122"/>
+                <a:cs typeface="Aptos" pitchFamily="34" charset="-120"/>
+              </a:rPr>
+              <a:t>Run the prepared Agent Framework WeatherAgent sample, then refresh the trace list.</a:t>
+            </a:r>
+            <a:endParaRPr lang="en-US" sz="1540" dirty="0"/>
+          </a:p>
+          <a:p>
+            <a:pPr indent="0" marL="0">
+              <a:buNone/>
+            </a:pPr>
+            <a:r>
+              <a:rPr lang="en-US" sz="1540" dirty="0">
+                <a:solidFill>
+                  <a:srgbClr val="E5EBF0"/>
+                </a:solidFill>
+                <a:latin typeface="Aptos" pitchFamily="34" charset="0"/>
+                <a:ea typeface="Aptos" pitchFamily="34" charset="-122"/>
+                <a:cs typeface="Aptos" pitchFamily="34" charset="-120"/>
+              </a:rPr>
+              <a:t>Open Weather Agent Chat and inspect the recorded agent, model, and tool spans.</a:t>
+            </a:r>
+            <a:endParaRPr lang="en-US" sz="1540" dirty="0"/>
+          </a:p>
+        </p:txBody>
+      </p:sp>
+      <p:sp>
+        <p:nvSpPr>
+          <p:cNvPr id="7" name="Shape 5"/>
+          <p:cNvSpPr/>
+          <p:nvPr/>
+        </p:nvSpPr>
+        <p:spPr>
+          <a:xfrm>
+            <a:off x="7452360" y="749808"/>
+            <a:ext cx="4041648" cy="5074920"/>
+          </a:xfrm>
+          <a:prstGeom prst="roundRect">
+            <a:avLst>
+              <a:gd name="adj" fmla="val 1810"/>
+            </a:avLst>
+          </a:prstGeom>
+          <a:solidFill>
+            <a:srgbClr val="FFFFFF"/>
+          </a:solidFill>
+          <a:ln/>
+        </p:spPr>
+      </p:sp>
+      <p:sp>
+        <p:nvSpPr>
+          <p:cNvPr id="8" name="Shape 6"/>
+          <p:cNvSpPr/>
+          <p:nvPr/>
+        </p:nvSpPr>
+        <p:spPr>
+          <a:xfrm>
+            <a:off x="7726680" y="1060704"/>
+            <a:ext cx="1225296" cy="347472"/>
+          </a:xfrm>
+          <a:prstGeom prst="roundRect">
+            <a:avLst>
+              <a:gd name="adj" fmla="val 21053"/>
+            </a:avLst>
+          </a:prstGeom>
+          <a:solidFill>
+            <a:srgbClr val="B88AF7"/>
+          </a:solidFill>
+          <a:ln/>
+        </p:spPr>
+      </p:sp>
+      <p:sp>
+        <p:nvSpPr>
+          <p:cNvPr id="9" name="Text 7"/>
+          <p:cNvSpPr/>
+          <p:nvPr/>
+        </p:nvSpPr>
+        <p:spPr>
+          <a:xfrm>
+            <a:off x="7836408" y="1170432"/>
+            <a:ext cx="1005840" cy="109728"/>
+          </a:xfrm>
+          <a:prstGeom prst="rect">
+            <a:avLst/>
+          </a:prstGeom>
+          <a:noFill/>
+          <a:ln/>
+        </p:spPr>
+        <p:txBody>
+          <a:bodyPr wrap="square" lIns="0" tIns="0" rIns="0" bIns="0" rtlCol="0" anchor="ctr"/>
+          <a:lstStyle/>
+          <a:p>
+            <a:pPr algn="ctr" indent="0" marL="0">
+              <a:buNone/>
+            </a:pPr>
+            <a:r>
+              <a:rPr lang="en-US" sz="950" b="1" dirty="0">
+                <a:solidFill>
+                  <a:srgbClr val="28143F"/>
+                </a:solidFill>
+                <a:latin typeface="Aptos" pitchFamily="34" charset="0"/>
+                <a:ea typeface="Aptos" pitchFamily="34" charset="-122"/>
+                <a:cs typeface="Aptos" pitchFamily="34" charset="-120"/>
+              </a:rPr>
+              <a:t>~6 min</a:t>
+            </a:r>
+            <a:endParaRPr lang="en-US" sz="950" dirty="0"/>
+          </a:p>
+        </p:txBody>
+      </p:sp>
+      <p:sp>
+        <p:nvSpPr>
+          <p:cNvPr id="10" name="Text 8"/>
+          <p:cNvSpPr/>
+          <p:nvPr/>
+        </p:nvSpPr>
+        <p:spPr>
+          <a:xfrm>
+            <a:off x="7726680" y="1719072"/>
+            <a:ext cx="2971800" cy="274320"/>
+          </a:xfrm>
+          <a:prstGeom prst="rect">
+            <a:avLst/>
+          </a:prstGeom>
+          <a:noFill/>
+          <a:ln/>
+        </p:spPr>
+        <p:txBody>
+          <a:bodyPr wrap="square" lIns="0" tIns="0" rIns="0" bIns="0" rtlCol="0" anchor="ctr"/>
+          <a:lstStyle/>
+          <a:p>
+            <a:pPr indent="0" marL="0">
+              <a:buNone/>
+            </a:pPr>
+            <a:r>
+              <a:rPr lang="en-US" sz="2100" b="1" dirty="0">
+                <a:solidFill>
+                  <a:srgbClr val="28143F"/>
+                </a:solidFill>
+                <a:latin typeface="Aptos Display" pitchFamily="34" charset="0"/>
+                <a:ea typeface="Aptos Display" pitchFamily="34" charset="-122"/>
+                <a:cs typeface="Aptos Display" pitchFamily="34" charset="-120"/>
+              </a:rPr>
+              <a:t>WATCH FOR</a:t>
+            </a:r>
+            <a:endParaRPr lang="en-US" sz="2100" dirty="0"/>
+          </a:p>
+        </p:txBody>
+      </p:sp>
+      <p:sp>
+        <p:nvSpPr>
+          <p:cNvPr id="11" name="Shape 9"/>
+          <p:cNvSpPr/>
+          <p:nvPr/>
+        </p:nvSpPr>
+        <p:spPr>
+          <a:xfrm>
+            <a:off x="7772400" y="2340864"/>
+            <a:ext cx="384048" cy="384048"/>
+          </a:xfrm>
+          <a:prstGeom prst="ellipse">
+            <a:avLst/>
+          </a:prstGeom>
+          <a:solidFill>
+            <a:srgbClr val="B88AF7"/>
+          </a:solidFill>
+          <a:ln/>
+        </p:spPr>
+      </p:sp>
+      <p:sp>
+        <p:nvSpPr>
+          <p:cNvPr id="12" name="Text 10"/>
+          <p:cNvSpPr/>
+          <p:nvPr/>
+        </p:nvSpPr>
+        <p:spPr>
+          <a:xfrm>
+            <a:off x="7772400" y="2459736"/>
+            <a:ext cx="384048" cy="100584"/>
+          </a:xfrm>
+          <a:prstGeom prst="rect">
+            <a:avLst/>
+          </a:prstGeom>
+          <a:noFill/>
+          <a:ln/>
+        </p:spPr>
+        <p:txBody>
+          <a:bodyPr wrap="square" lIns="0" tIns="0" rIns="0" bIns="0" rtlCol="0" anchor="ctr"/>
+          <a:lstStyle/>
+          <a:p>
+            <a:pPr algn="ctr" indent="0" marL="0">
+              <a:buNone/>
+            </a:pPr>
+            <a:r>
+              <a:rPr lang="en-US" sz="900" b="1" dirty="0">
+                <a:solidFill>
+                  <a:srgbClr val="28143F"/>
+                </a:solidFill>
+                <a:latin typeface="Aptos" pitchFamily="34" charset="0"/>
+                <a:ea typeface="Aptos" pitchFamily="34" charset="-122"/>
+                <a:cs typeface="Aptos" pitchFamily="34" charset="-120"/>
+              </a:rPr>
+              <a:t>1</a:t>
+            </a:r>
+            <a:endParaRPr lang="en-US" sz="900" dirty="0"/>
+          </a:p>
+        </p:txBody>
+      </p:sp>
+      <p:sp>
+        <p:nvSpPr>
+          <p:cNvPr id="13" name="Text 11"/>
+          <p:cNvSpPr/>
+          <p:nvPr/>
+        </p:nvSpPr>
+        <p:spPr>
+          <a:xfrm>
+            <a:off x="8339328" y="2286000"/>
+            <a:ext cx="2889504" cy="512064"/>
+          </a:xfrm>
+          <a:prstGeom prst="rect">
+            <a:avLst/>
+          </a:prstGeom>
+          <a:noFill/>
+          <a:ln/>
+        </p:spPr>
+        <p:txBody>
+          <a:bodyPr wrap="square" lIns="0" tIns="0" rIns="0" bIns="0" rtlCol="0" anchor="ctr">
+            <a:normAutofit/>
+          </a:bodyPr>
+          <a:lstStyle/>
+          <a:p>
+            <a:pPr indent="0" marL="0">
+              <a:buNone/>
+            </a:pPr>
+            <a:r>
+              <a:rPr lang="en-US" sz="1480" b="1" dirty="0">
+                <a:solidFill>
+                  <a:srgbClr val="251B33"/>
+                </a:solidFill>
+                <a:latin typeface="Aptos" pitchFamily="34" charset="0"/>
+                <a:ea typeface="Aptos" pitchFamily="34" charset="-122"/>
+                <a:cs typeface="Aptos" pitchFamily="34" charset="-120"/>
+              </a:rPr>
+              <a:t>Collector listens on localhost:4317</a:t>
+            </a:r>
+            <a:endParaRPr lang="en-US" sz="1480" dirty="0"/>
+          </a:p>
+        </p:txBody>
+      </p:sp>
+      <p:sp>
+        <p:nvSpPr>
+          <p:cNvPr id="14" name="Shape 12"/>
+          <p:cNvSpPr/>
+          <p:nvPr/>
+        </p:nvSpPr>
+        <p:spPr>
+          <a:xfrm>
+            <a:off x="7772400" y="3127248"/>
+            <a:ext cx="384048" cy="384048"/>
+          </a:xfrm>
+          <a:prstGeom prst="ellipse">
+            <a:avLst/>
+          </a:prstGeom>
+          <a:solidFill>
+            <a:srgbClr val="B88AF7"/>
+          </a:solidFill>
+          <a:ln/>
+        </p:spPr>
+      </p:sp>
+      <p:sp>
+        <p:nvSpPr>
+          <p:cNvPr id="15" name="Text 13"/>
+          <p:cNvSpPr/>
+          <p:nvPr/>
+        </p:nvSpPr>
+        <p:spPr>
+          <a:xfrm>
+            <a:off x="7772400" y="3246120"/>
+            <a:ext cx="384048" cy="100584"/>
+          </a:xfrm>
+          <a:prstGeom prst="rect">
+            <a:avLst/>
+          </a:prstGeom>
+          <a:noFill/>
+          <a:ln/>
+        </p:spPr>
+        <p:txBody>
+          <a:bodyPr wrap="square" lIns="0" tIns="0" rIns="0" bIns="0" rtlCol="0" anchor="ctr"/>
+          <a:lstStyle/>
+          <a:p>
+            <a:pPr algn="ctr" indent="0" marL="0">
+              <a:buNone/>
+            </a:pPr>
+            <a:r>
+              <a:rPr lang="en-US" sz="900" b="1" dirty="0">
+                <a:solidFill>
+                  <a:srgbClr val="28143F"/>
+                </a:solidFill>
+                <a:latin typeface="Aptos" pitchFamily="34" charset="0"/>
+                <a:ea typeface="Aptos" pitchFamily="34" charset="-122"/>
+                <a:cs typeface="Aptos" pitchFamily="34" charset="-120"/>
+              </a:rPr>
+              <a:t>2</a:t>
+            </a:r>
+            <a:endParaRPr lang="en-US" sz="900" dirty="0"/>
+          </a:p>
+        </p:txBody>
+      </p:sp>
+      <p:sp>
+        <p:nvSpPr>
+          <p:cNvPr id="16" name="Text 14"/>
+          <p:cNvSpPr/>
+          <p:nvPr/>
+        </p:nvSpPr>
+        <p:spPr>
+          <a:xfrm>
+            <a:off x="8339328" y="3072384"/>
+            <a:ext cx="2889504" cy="512064"/>
+          </a:xfrm>
+          <a:prstGeom prst="rect">
+            <a:avLst/>
+          </a:prstGeom>
+          <a:noFill/>
+          <a:ln/>
+        </p:spPr>
+        <p:txBody>
+          <a:bodyPr wrap="square" lIns="0" tIns="0" rIns="0" bIns="0" rtlCol="0" anchor="ctr">
+            <a:normAutofit/>
+          </a:bodyPr>
+          <a:lstStyle/>
+          <a:p>
+            <a:pPr indent="0" marL="0">
+              <a:buNone/>
+            </a:pPr>
+            <a:r>
+              <a:rPr lang="en-US" sz="1480" b="1" dirty="0">
+                <a:solidFill>
+                  <a:srgbClr val="251B33"/>
+                </a:solidFill>
+                <a:latin typeface="Aptos" pitchFamily="34" charset="0"/>
+                <a:ea typeface="Aptos" pitchFamily="34" charset="-122"/>
+                <a:cs typeface="Aptos" pitchFamily="34" charset="-120"/>
+              </a:rPr>
+              <a:t>Local trace storage ≠ local inference</a:t>
+            </a:r>
+            <a:endParaRPr lang="en-US" sz="1480" dirty="0"/>
+          </a:p>
+        </p:txBody>
+      </p:sp>
+      <p:sp>
+        <p:nvSpPr>
+          <p:cNvPr id="17" name="Shape 15"/>
+          <p:cNvSpPr/>
+          <p:nvPr/>
+        </p:nvSpPr>
+        <p:spPr>
+          <a:xfrm>
+            <a:off x="7772400" y="3913632"/>
+            <a:ext cx="384048" cy="384048"/>
+          </a:xfrm>
+          <a:prstGeom prst="ellipse">
+            <a:avLst/>
+          </a:prstGeom>
+          <a:solidFill>
+            <a:srgbClr val="FFB454"/>
+          </a:solidFill>
+          <a:ln/>
+        </p:spPr>
+      </p:sp>
+      <p:sp>
+        <p:nvSpPr>
+          <p:cNvPr id="18" name="Text 16"/>
+          <p:cNvSpPr/>
+          <p:nvPr/>
+        </p:nvSpPr>
+        <p:spPr>
+          <a:xfrm>
+            <a:off x="7772400" y="4032504"/>
+            <a:ext cx="384048" cy="100584"/>
+          </a:xfrm>
+          <a:prstGeom prst="rect">
+            <a:avLst/>
+          </a:prstGeom>
+          <a:noFill/>
+          <a:ln/>
+        </p:spPr>
+        <p:txBody>
+          <a:bodyPr wrap="square" lIns="0" tIns="0" rIns="0" bIns="0" rtlCol="0" anchor="ctr"/>
+          <a:lstStyle/>
+          <a:p>
+            <a:pPr algn="ctr" indent="0" marL="0">
+              <a:buNone/>
+            </a:pPr>
+            <a:r>
+              <a:rPr lang="en-US" sz="900" b="1" dirty="0">
+                <a:solidFill>
+                  <a:srgbClr val="28143F"/>
+                </a:solidFill>
+                <a:latin typeface="Aptos" pitchFamily="34" charset="0"/>
+                <a:ea typeface="Aptos" pitchFamily="34" charset="-122"/>
+                <a:cs typeface="Aptos" pitchFamily="34" charset="-120"/>
+              </a:rPr>
+              <a:t>3</a:t>
+            </a:r>
+            <a:endParaRPr lang="en-US" sz="900" dirty="0"/>
+          </a:p>
+        </p:txBody>
+      </p:sp>
+      <p:sp>
+        <p:nvSpPr>
+          <p:cNvPr id="19" name="Text 17"/>
+          <p:cNvSpPr/>
+          <p:nvPr/>
+        </p:nvSpPr>
+        <p:spPr>
+          <a:xfrm>
+            <a:off x="8339328" y="3858768"/>
+            <a:ext cx="2889504" cy="512064"/>
+          </a:xfrm>
+          <a:prstGeom prst="rect">
+            <a:avLst/>
+          </a:prstGeom>
+          <a:noFill/>
+          <a:ln/>
+        </p:spPr>
+        <p:txBody>
+          <a:bodyPr wrap="square" lIns="0" tIns="0" rIns="0" bIns="0" rtlCol="0" anchor="ctr">
+            <a:normAutofit/>
+          </a:bodyPr>
+          <a:lstStyle/>
+          <a:p>
+            <a:pPr indent="0" marL="0">
+              <a:buNone/>
+            </a:pPr>
+            <a:r>
+              <a:rPr lang="en-US" sz="1480" b="1" dirty="0">
+                <a:solidFill>
+                  <a:srgbClr val="251B33"/>
+                </a:solidFill>
+                <a:latin typeface="Aptos" pitchFamily="34" charset="0"/>
+                <a:ea typeface="Aptos" pitchFamily="34" charset="-122"/>
+                <a:cs typeface="Aptos" pitchFamily="34" charset="-120"/>
+              </a:rPr>
+              <a:t>Synthetic content capture only</a:t>
+            </a:r>
+            <a:endParaRPr lang="en-US" sz="1480" dirty="0"/>
+          </a:p>
+        </p:txBody>
+      </p:sp>
+      <p:sp>
+        <p:nvSpPr>
+          <p:cNvPr id="20" name="Shape 18"/>
+          <p:cNvSpPr/>
+          <p:nvPr/>
+        </p:nvSpPr>
+        <p:spPr>
+          <a:xfrm>
+            <a:off x="7726680" y="4882896"/>
+            <a:ext cx="3401568" cy="566928"/>
+          </a:xfrm>
+          <a:prstGeom prst="roundRect">
+            <a:avLst>
+              <a:gd name="adj" fmla="val 12903"/>
+            </a:avLst>
+          </a:prstGeom>
+          <a:solidFill>
+            <a:srgbClr val="F1E8FD"/>
+          </a:solidFill>
+          <a:ln/>
+        </p:spPr>
+      </p:sp>
+      <p:sp>
+        <p:nvSpPr>
+          <p:cNvPr id="21" name="Text 19"/>
+          <p:cNvSpPr/>
+          <p:nvPr/>
+        </p:nvSpPr>
+        <p:spPr>
+          <a:xfrm>
+            <a:off x="7882128" y="5029200"/>
+            <a:ext cx="3090672" cy="201168"/>
+          </a:xfrm>
+          <a:prstGeom prst="rect">
+            <a:avLst/>
+          </a:prstGeom>
+          <a:noFill/>
+          <a:ln/>
+        </p:spPr>
+        <p:txBody>
+          <a:bodyPr wrap="square" lIns="0" tIns="0" rIns="0" bIns="0" rtlCol="0" anchor="ctr">
+            <a:normAutofit/>
+          </a:bodyPr>
+          <a:lstStyle/>
+          <a:p>
+            <a:pPr indent="0" marL="0">
+              <a:buNone/>
+            </a:pPr>
+            <a:r>
+              <a:rPr lang="en-US" sz="1100" dirty="0">
+                <a:solidFill>
+                  <a:srgbClr val="28143F"/>
+                </a:solidFill>
+                <a:latin typeface="Consolas" pitchFamily="34" charset="0"/>
+                <a:ea typeface="Consolas" pitchFamily="34" charset="-122"/>
+                <a:cs typeface="Consolas" pitchFamily="34" charset="-120"/>
+              </a:rPr>
+              <a:t>demos/day5/module-2-demo-2-trace-local-code.md</a:t>
+            </a:r>
+            <a:endParaRPr lang="en-US" sz="1100" dirty="0"/>
+          </a:p>
+        </p:txBody>
+      </p:sp>
+      <p:sp>
+        <p:nvSpPr>
+          <p:cNvPr id="22" name="Text 20"/>
+          <p:cNvSpPr/>
+          <p:nvPr/>
+        </p:nvSpPr>
+        <p:spPr>
+          <a:xfrm>
+            <a:off x="658368" y="6318504"/>
+            <a:ext cx="10881360" cy="182880"/>
+          </a:xfrm>
+          <a:prstGeom prst="rect">
+            <a:avLst/>
+          </a:prstGeom>
+          <a:noFill/>
+          <a:ln/>
+        </p:spPr>
+        <p:txBody>
+          <a:bodyPr wrap="square" lIns="0" tIns="0" rIns="0" bIns="0" rtlCol="0" anchor="ctr">
+            <a:normAutofit/>
+          </a:bodyPr>
+          <a:lstStyle/>
+          <a:p>
+            <a:pPr indent="0" marL="0">
+              <a:buNone/>
+            </a:pPr>
+            <a:r>
+              <a:rPr lang="en-US" sz="940" dirty="0">
+                <a:solidFill>
+                  <a:srgbClr val="DDE7EF"/>
+                </a:solidFill>
+                <a:latin typeface="Aptos" pitchFamily="34" charset="0"/>
+                <a:ea typeface="Aptos" pitchFamily="34" charset="-122"/>
+                <a:cs typeface="Aptos" pitchFamily="34" charset="-120"/>
+              </a:rPr>
+              <a:t>REFERENCE  code.visualstudio.com/docs/intelligentapps/tracing  ·  +1 more in notes</a:t>
+            </a:r>
+            <a:endParaRPr lang="en-US" sz="940" dirty="0"/>
+          </a:p>
+        </p:txBody>
+      </p:sp>
+      <p:sp>
+        <p:nvSpPr>
+          <p:cNvPr id="23" name="Shape 21"/>
           <p:cNvSpPr/>
           <p:nvPr/>
         </p:nvSpPr>

</xml_diff>